<commit_message>
Add a stakeholder-level positioning slide
The brief asks why each stakeholder would choose this over what they use
today. The deck positioned only for the chosen first user, which left that
requirement half-answered.

New slide 16 covers all six remaining stakeholder groups: what each uses
today, what they would need from this, and an honest status — serving now,
needs coverage, or not yet. It makes the deliberate narrowing visible
rather than looking like an omission.

It also addresses the brief's "how much" directly: no credible public
figure for the cost of the asymmetry could be found, so none is given, and
the slide names the measurement that would produce one.

Deck is now 19 slides.

Co-Authored-By: Claude Opus 5 <noreply@anthropic.com>
Claude-Session: https://claude.ai/code/session_01EyYbwKWuJPpGjmxdD5DADm
</commit_message>
<xml_diff>
--- a/gcc-atlas/deck/GCC-Atlas-Flexiple-Assignment.pptx
+++ b/gcc-atlas/deck/GCC-Atlas-Flexiple-Assignment.pptx
@@ -23,6 +23,7 @@
     <p:sldId id="271" r:id="rId22"/>
     <p:sldId id="272" r:id="rId23"/>
     <p:sldId id="273" r:id="rId24"/>
+    <p:sldId id="274" r:id="rId25"/>
   </p:sldIdLst>
   <p:sldSz cx="12191695" cy="6858000" type="screen4x3"/>
   <p:notesSz cx="6858000" cy="9144000"/>
@@ -8093,7 +8094,7 @@
                 </a:solidFill>
                 <a:latin typeface="Calibri"/>
               </a:rPr>
-              <a:t>HONESTY</a:t>
+              <a:t>POSITIONING</a:t>
             </a:r>
           </a:p>
         </p:txBody>
@@ -8132,13 +8133,13 @@
               </a:spcAft>
             </a:pPr>
             <a:r>
-              <a:rPr sz="3200" b="0" i="0">
+              <a:rPr sz="2900" b="0" i="0">
                 <a:solidFill>
                   <a:srgbClr val="1A1A1A"/>
                 </a:solidFill>
                 <a:latin typeface="Georgia"/>
               </a:rPr>
-              <a:t>What is not true about this yet</a:t>
+              <a:t>What it would take to serve the rest of the ecosystem</a:t>
             </a:r>
           </a:p>
         </p:txBody>
@@ -8177,13 +8178,13 @@
               </a:spcAft>
             </a:pPr>
             <a:r>
-              <a:rPr sz="1450" b="0" i="0">
+              <a:rPr sz="1350" b="0" i="0">
                 <a:solidFill>
                   <a:srgbClr val="4A4845"/>
                 </a:solidFill>
                 <a:latin typeface="Calibri"/>
               </a:rPr>
-              <a:t>Stated here rather than discovered later. The product repeats all of this on its own Sources &amp; Method page.</a:t>
+              <a:t>I built for one stakeholder on purpose. Here is what each of the others would need before this is worth their time — and which of those I can honestly serve today.</a:t>
             </a:r>
           </a:p>
         </p:txBody>
@@ -8196,7 +8197,7 @@
         </p:nvSpPr>
         <p:spPr>
           <a:xfrm>
-            <a:off x="713232" y="2121408"/>
+            <a:off x="713232" y="2139696"/>
             <a:ext cx="10765231" cy="11430"/>
           </a:xfrm>
           <a:prstGeom prst="rect">
@@ -8234,20 +8235,200 @@
       </p:sp>
       <p:sp>
         <p:nvSpPr>
-          <p:cNvPr id="7" name="Rectangle 6"/>
+          <p:cNvPr id="7" name="TextBox 6"/>
+          <p:cNvSpPr txBox="1"/>
+          <p:nvPr/>
+        </p:nvSpPr>
+        <p:spPr>
+          <a:xfrm>
+            <a:off x="713232" y="2304288"/>
+            <a:ext cx="2286000" cy="228600"/>
+          </a:xfrm>
+          <a:prstGeom prst="rect">
+            <a:avLst/>
+          </a:prstGeom>
+          <a:noFill/>
+        </p:spPr>
+        <p:txBody>
+          <a:bodyPr wrap="square" lIns="0" rIns="0" tIns="0" bIns="0" anchor="t">
+            <a:spAutoFit/>
+          </a:bodyPr>
+          <a:lstStyle/>
+          <a:p>
+            <a:pPr algn="l">
+              <a:lnSpc>
+                <a:spcPct val="135000"/>
+              </a:lnSpc>
+              <a:spcBef>
+                <a:spcPts val="0"/>
+              </a:spcBef>
+              <a:spcAft>
+                <a:spcPts val="0"/>
+              </a:spcAft>
+            </a:pPr>
+            <a:r>
+              <a:rPr sz="950" b="1" i="0">
+                <a:solidFill>
+                  <a:srgbClr val="7A7772"/>
+                </a:solidFill>
+                <a:latin typeface="Calibri"/>
+              </a:rPr>
+              <a:t>STAKEHOLDER</a:t>
+            </a:r>
+          </a:p>
+        </p:txBody>
+      </p:sp>
+      <p:sp>
+        <p:nvSpPr>
+          <p:cNvPr id="8" name="TextBox 7"/>
+          <p:cNvSpPr txBox="1"/>
+          <p:nvPr/>
+        </p:nvSpPr>
+        <p:spPr>
+          <a:xfrm>
+            <a:off x="3108960" y="2304288"/>
+            <a:ext cx="2743200" cy="228600"/>
+          </a:xfrm>
+          <a:prstGeom prst="rect">
+            <a:avLst/>
+          </a:prstGeom>
+          <a:noFill/>
+        </p:spPr>
+        <p:txBody>
+          <a:bodyPr wrap="square" lIns="0" rIns="0" tIns="0" bIns="0" anchor="t">
+            <a:spAutoFit/>
+          </a:bodyPr>
+          <a:lstStyle/>
+          <a:p>
+            <a:pPr algn="l">
+              <a:lnSpc>
+                <a:spcPct val="135000"/>
+              </a:lnSpc>
+              <a:spcBef>
+                <a:spcPts val="0"/>
+              </a:spcBef>
+              <a:spcAft>
+                <a:spcPts val="0"/>
+              </a:spcAft>
+            </a:pPr>
+            <a:r>
+              <a:rPr sz="950" b="1" i="0">
+                <a:solidFill>
+                  <a:srgbClr val="7A7772"/>
+                </a:solidFill>
+                <a:latin typeface="Calibri"/>
+              </a:rPr>
+              <a:t>WHAT THEY USE TODAY</a:t>
+            </a:r>
+          </a:p>
+        </p:txBody>
+      </p:sp>
+      <p:sp>
+        <p:nvSpPr>
+          <p:cNvPr id="9" name="TextBox 8"/>
+          <p:cNvSpPr txBox="1"/>
+          <p:nvPr/>
+        </p:nvSpPr>
+        <p:spPr>
+          <a:xfrm>
+            <a:off x="5961888" y="2304288"/>
+            <a:ext cx="3931920" cy="228600"/>
+          </a:xfrm>
+          <a:prstGeom prst="rect">
+            <a:avLst/>
+          </a:prstGeom>
+          <a:noFill/>
+        </p:spPr>
+        <p:txBody>
+          <a:bodyPr wrap="square" lIns="0" rIns="0" tIns="0" bIns="0" anchor="t">
+            <a:spAutoFit/>
+          </a:bodyPr>
+          <a:lstStyle/>
+          <a:p>
+            <a:pPr algn="l">
+              <a:lnSpc>
+                <a:spcPct val="135000"/>
+              </a:lnSpc>
+              <a:spcBef>
+                <a:spcPts val="0"/>
+              </a:spcBef>
+              <a:spcAft>
+                <a:spcPts val="0"/>
+              </a:spcAft>
+            </a:pPr>
+            <a:r>
+              <a:rPr sz="950" b="1" i="0">
+                <a:solidFill>
+                  <a:srgbClr val="7A7772"/>
+                </a:solidFill>
+                <a:latin typeface="Calibri"/>
+              </a:rPr>
+              <a:t>WHAT THEY WOULD NEED FROM THIS</a:t>
+            </a:r>
+          </a:p>
+        </p:txBody>
+      </p:sp>
+      <p:sp>
+        <p:nvSpPr>
+          <p:cNvPr id="10" name="TextBox 9"/>
+          <p:cNvSpPr txBox="1"/>
+          <p:nvPr/>
+        </p:nvSpPr>
+        <p:spPr>
+          <a:xfrm>
+            <a:off x="10003536" y="2304288"/>
+            <a:ext cx="1371600" cy="228600"/>
+          </a:xfrm>
+          <a:prstGeom prst="rect">
+            <a:avLst/>
+          </a:prstGeom>
+          <a:noFill/>
+        </p:spPr>
+        <p:txBody>
+          <a:bodyPr wrap="square" lIns="0" rIns="0" tIns="0" bIns="0" anchor="t">
+            <a:spAutoFit/>
+          </a:bodyPr>
+          <a:lstStyle/>
+          <a:p>
+            <a:pPr algn="l">
+              <a:lnSpc>
+                <a:spcPct val="135000"/>
+              </a:lnSpc>
+              <a:spcBef>
+                <a:spcPts val="0"/>
+              </a:spcBef>
+              <a:spcAft>
+                <a:spcPts val="0"/>
+              </a:spcAft>
+            </a:pPr>
+            <a:r>
+              <a:rPr sz="950" b="1" i="0">
+                <a:solidFill>
+                  <a:srgbClr val="7A7772"/>
+                </a:solidFill>
+                <a:latin typeface="Calibri"/>
+              </a:rPr>
+              <a:t>STATUS</a:t>
+            </a:r>
+          </a:p>
+        </p:txBody>
+      </p:sp>
+      <p:sp>
+        <p:nvSpPr>
+          <p:cNvPr id="11" name="Rectangle 10"/>
           <p:cNvSpPr/>
           <p:nvPr/>
         </p:nvSpPr>
         <p:spPr>
           <a:xfrm>
-            <a:off x="713232" y="2395728"/>
-            <a:ext cx="33020" cy="658368"/>
+            <a:off x="713232" y="2578608"/>
+            <a:ext cx="10765231" cy="11430"/>
           </a:xfrm>
           <a:prstGeom prst="rect">
             <a:avLst/>
           </a:prstGeom>
           <a:solidFill>
-            <a:srgbClr val="7D3B36"/>
+            <a:srgbClr val="E2DED7"/>
           </a:solidFill>
           <a:ln>
             <a:noFill/>
@@ -8278,14 +8459,14 @@
       </p:sp>
       <p:sp>
         <p:nvSpPr>
-          <p:cNvPr id="8" name="TextBox 7"/>
-          <p:cNvSpPr txBox="1"/>
-          <p:nvPr/>
-        </p:nvSpPr>
-        <p:spPr>
-          <a:xfrm>
-            <a:off x="914400" y="2395728"/>
-            <a:ext cx="10564063" cy="658368"/>
+          <p:cNvPr id="12" name="TextBox 11"/>
+          <p:cNvSpPr txBox="1"/>
+          <p:nvPr/>
+        </p:nvSpPr>
+        <p:spPr>
+          <a:xfrm>
+            <a:off x="713232" y="2706624"/>
+            <a:ext cx="2286000" cy="548640"/>
           </a:xfrm>
           <a:prstGeom prst="rect">
             <a:avLst/>
@@ -8300,65 +8481,133 @@
           <a:p>
             <a:pPr algn="l">
               <a:lnSpc>
-                <a:spcPct val="135000"/>
-              </a:lnSpc>
-              <a:spcBef>
-                <a:spcPts val="0"/>
-              </a:spcBef>
-              <a:spcAft>
-                <a:spcPts val="300"/>
-              </a:spcAft>
-            </a:pPr>
-            <a:r>
-              <a:rPr sz="1250" b="1" i="0">
+                <a:spcPct val="125000"/>
+              </a:lnSpc>
+              <a:spcBef>
+                <a:spcPts val="0"/>
+              </a:spcBef>
+              <a:spcAft>
+                <a:spcPts val="0"/>
+              </a:spcAft>
+            </a:pPr>
+            <a:r>
+              <a:rPr sz="1100" b="1" i="0">
                 <a:solidFill>
                   <a:srgbClr val="1A1A1A"/>
                 </a:solidFill>
                 <a:latin typeface="Calibri"/>
               </a:rPr>
-              <a:t>The source links are not yet confirmed first-hand</a:t>
-            </a:r>
-          </a:p>
-          <a:p>
-            <a:pPr>
-              <a:lnSpc>
-                <a:spcPct val="133000"/>
-              </a:lnSpc>
-              <a:spcBef>
-                <a:spcPts val="0"/>
-              </a:spcBef>
-              <a:spcAft>
-                <a:spcPts val="600"/>
-              </a:spcAft>
-            </a:pPr>
-            <a:r>
-              <a:rPr sz="1100" b="0" i="0">
-                <a:solidFill>
-                  <a:srgbClr val="4A4845"/>
-                </a:solidFill>
-                <a:latin typeface="Calibri"/>
-              </a:rPr>
-              <a:t>I identified them through search. The build environment blocked opening pages directly, so each link still needs to be read and confirmed. The app ships a Verify checklist for exactly this, and nothing should be presented as fact until that is done.</a:t>
-            </a:r>
-          </a:p>
-        </p:txBody>
-      </p:sp>
-      <p:sp>
-        <p:nvSpPr>
-          <p:cNvPr id="9" name="Rectangle 8"/>
+              <a:t>Recruitment &amp; staffing</a:t>
+            </a:r>
+          </a:p>
+        </p:txBody>
+      </p:sp>
+      <p:sp>
+        <p:nvSpPr>
+          <p:cNvPr id="13" name="TextBox 12"/>
+          <p:cNvSpPr txBox="1"/>
+          <p:nvPr/>
+        </p:nvSpPr>
+        <p:spPr>
+          <a:xfrm>
+            <a:off x="3108960" y="2706624"/>
+            <a:ext cx="2743200" cy="548640"/>
+          </a:xfrm>
+          <a:prstGeom prst="rect">
+            <a:avLst/>
+          </a:prstGeom>
+          <a:noFill/>
+        </p:spPr>
+        <p:txBody>
+          <a:bodyPr wrap="square" lIns="0" rIns="0" tIns="0" bIns="0" anchor="t">
+            <a:spAutoFit/>
+          </a:bodyPr>
+          <a:lstStyle/>
+          <a:p>
+            <a:pPr algn="l">
+              <a:lnSpc>
+                <a:spcPct val="128000"/>
+              </a:lnSpc>
+              <a:spcBef>
+                <a:spcPts val="0"/>
+              </a:spcBef>
+              <a:spcAft>
+                <a:spcPts val="0"/>
+              </a:spcAft>
+            </a:pPr>
+            <a:r>
+              <a:rPr sz="1050" b="0" i="0">
+                <a:solidFill>
+                  <a:srgbClr val="7A7772"/>
+                </a:solidFill>
+                <a:latin typeface="Calibri"/>
+              </a:rPr>
+              <a:t>News, referrals, generic sales tools</a:t>
+            </a:r>
+          </a:p>
+        </p:txBody>
+      </p:sp>
+      <p:sp>
+        <p:nvSpPr>
+          <p:cNvPr id="14" name="TextBox 13"/>
+          <p:cNvSpPr txBox="1"/>
+          <p:nvPr/>
+        </p:nvSpPr>
+        <p:spPr>
+          <a:xfrm>
+            <a:off x="5961888" y="2706624"/>
+            <a:ext cx="3931920" cy="548640"/>
+          </a:xfrm>
+          <a:prstGeom prst="rect">
+            <a:avLst/>
+          </a:prstGeom>
+          <a:noFill/>
+        </p:spPr>
+        <p:txBody>
+          <a:bodyPr wrap="square" lIns="0" rIns="0" tIns="0" bIns="0" anchor="t">
+            <a:spAutoFit/>
+          </a:bodyPr>
+          <a:lstStyle/>
+          <a:p>
+            <a:pPr algn="l">
+              <a:lnSpc>
+                <a:spcPct val="128000"/>
+              </a:lnSpc>
+              <a:spcBef>
+                <a:spcPts val="0"/>
+              </a:spcBef>
+              <a:spcAft>
+                <a:spcPts val="0"/>
+              </a:spcAft>
+            </a:pPr>
+            <a:r>
+              <a:rPr sz="1050" b="0" i="0">
+                <a:solidFill>
+                  <a:srgbClr val="1A1A1A"/>
+                </a:solidFill>
+                <a:latin typeface="Calibri"/>
+              </a:rPr>
+              <a:t>Dated, cited, per-company activity they can check before acting</a:t>
+            </a:r>
+          </a:p>
+        </p:txBody>
+      </p:sp>
+      <p:sp>
+        <p:nvSpPr>
+          <p:cNvPr id="15" name="Rectangle 14"/>
           <p:cNvSpPr/>
           <p:nvPr/>
         </p:nvSpPr>
         <p:spPr>
           <a:xfrm>
-            <a:off x="713232" y="3182112"/>
-            <a:ext cx="33020" cy="658368"/>
+            <a:off x="10003536" y="2688336"/>
+            <a:ext cx="1371600" cy="237744"/>
           </a:xfrm>
           <a:prstGeom prst="rect">
             <a:avLst/>
           </a:prstGeom>
           <a:solidFill>
-            <a:srgbClr val="7D3B36"/>
+            <a:srgbClr val="E8F1ED"/>
           </a:solidFill>
           <a:ln>
             <a:noFill/>
@@ -8380,23 +8629,32 @@
           </a:fontRef>
         </p:style>
         <p:txBody>
-          <a:bodyPr rtlCol="0" anchor="ctr"/>
+          <a:bodyPr rtlCol="0" anchor="ctr" lIns="64008" rIns="64008" tIns="0" bIns="0"/>
           <a:lstStyle/>
           <a:p>
             <a:pPr algn="ctr"/>
-          </a:p>
-        </p:txBody>
-      </p:sp>
-      <p:sp>
-        <p:nvSpPr>
-          <p:cNvPr id="10" name="TextBox 9"/>
-          <p:cNvSpPr txBox="1"/>
-          <p:nvPr/>
-        </p:nvSpPr>
-        <p:spPr>
-          <a:xfrm>
-            <a:off x="914400" y="3182112"/>
-            <a:ext cx="10564063" cy="658368"/>
+            <a:r>
+              <a:rPr sz="950" b="1">
+                <a:solidFill>
+                  <a:srgbClr val="1D5C43"/>
+                </a:solidFill>
+                <a:latin typeface="Calibri"/>
+              </a:rPr>
+              <a:t>Serving now</a:t>
+            </a:r>
+          </a:p>
+        </p:txBody>
+      </p:sp>
+      <p:sp>
+        <p:nvSpPr>
+          <p:cNvPr id="16" name="TextBox 15"/>
+          <p:cNvSpPr txBox="1"/>
+          <p:nvPr/>
+        </p:nvSpPr>
+        <p:spPr>
+          <a:xfrm>
+            <a:off x="713232" y="3209544"/>
+            <a:ext cx="2286000" cy="548640"/>
           </a:xfrm>
           <a:prstGeom prst="rect">
             <a:avLst/>
@@ -8411,65 +8669,133 @@
           <a:p>
             <a:pPr algn="l">
               <a:lnSpc>
-                <a:spcPct val="135000"/>
-              </a:lnSpc>
-              <a:spcBef>
-                <a:spcPts val="0"/>
-              </a:spcBef>
-              <a:spcAft>
-                <a:spcPts val="300"/>
-              </a:spcAft>
-            </a:pPr>
-            <a:r>
-              <a:rPr sz="1250" b="1" i="0">
+                <a:spcPct val="125000"/>
+              </a:lnSpc>
+              <a:spcBef>
+                <a:spcPts val="0"/>
+              </a:spcBef>
+              <a:spcAft>
+                <a:spcPts val="0"/>
+              </a:spcAft>
+            </a:pPr>
+            <a:r>
+              <a:rPr sz="1100" b="1" i="0">
                 <a:solidFill>
                   <a:srgbClr val="1A1A1A"/>
                 </a:solidFill>
                 <a:latin typeface="Calibri"/>
               </a:rPr>
-              <a:t>No user research exists</a:t>
-            </a:r>
-          </a:p>
-          <a:p>
-            <a:pPr>
-              <a:lnSpc>
-                <a:spcPct val="133000"/>
-              </a:lnSpc>
-              <a:spcBef>
-                <a:spcPts val="0"/>
-              </a:spcBef>
-              <a:spcAft>
-                <a:spcPts val="600"/>
-              </a:spcAft>
-            </a:pPr>
-            <a:r>
-              <a:rPr sz="1100" b="0" i="0">
-                <a:solidFill>
-                  <a:srgbClr val="4A4845"/>
-                </a:solidFill>
-                <a:latin typeface="Calibri"/>
-              </a:rPr>
-              <a:t>I have not interviewed a single recruitment or staffing professional. Every statement about what they need is my reasoning, not a finding. The alternatives slide marks which claims I tested myself and which I assumed.</a:t>
-            </a:r>
-          </a:p>
-        </p:txBody>
-      </p:sp>
-      <p:sp>
-        <p:nvSpPr>
-          <p:cNvPr id="11" name="Rectangle 10"/>
+              <a:t>Advisors &amp; consultants</a:t>
+            </a:r>
+          </a:p>
+        </p:txBody>
+      </p:sp>
+      <p:sp>
+        <p:nvSpPr>
+          <p:cNvPr id="17" name="TextBox 16"/>
+          <p:cNvSpPr txBox="1"/>
+          <p:nvPr/>
+        </p:nvSpPr>
+        <p:spPr>
+          <a:xfrm>
+            <a:off x="3108960" y="3209544"/>
+            <a:ext cx="2743200" cy="548640"/>
+          </a:xfrm>
+          <a:prstGeom prst="rect">
+            <a:avLst/>
+          </a:prstGeom>
+          <a:noFill/>
+        </p:spPr>
+        <p:txBody>
+          <a:bodyPr wrap="square" lIns="0" rIns="0" tIns="0" bIns="0" anchor="t">
+            <a:spAutoFit/>
+          </a:bodyPr>
+          <a:lstStyle/>
+          <a:p>
+            <a:pPr algn="l">
+              <a:lnSpc>
+                <a:spcPct val="128000"/>
+              </a:lnSpc>
+              <a:spcBef>
+                <a:spcPts val="0"/>
+              </a:spcBef>
+              <a:spcAft>
+                <a:spcPts val="0"/>
+              </a:spcAft>
+            </a:pPr>
+            <a:r>
+              <a:rPr sz="1050" b="0" i="0">
+                <a:solidFill>
+                  <a:srgbClr val="7A7772"/>
+                </a:solidFill>
+                <a:latin typeface="Calibri"/>
+              </a:rPr>
+              <a:t>Their own networks; subscription research</a:t>
+            </a:r>
+          </a:p>
+        </p:txBody>
+      </p:sp>
+      <p:sp>
+        <p:nvSpPr>
+          <p:cNvPr id="18" name="TextBox 17"/>
+          <p:cNvSpPr txBox="1"/>
+          <p:nvPr/>
+        </p:nvSpPr>
+        <p:spPr>
+          <a:xfrm>
+            <a:off x="5961888" y="3209544"/>
+            <a:ext cx="3931920" cy="548640"/>
+          </a:xfrm>
+          <a:prstGeom prst="rect">
+            <a:avLst/>
+          </a:prstGeom>
+          <a:noFill/>
+        </p:spPr>
+        <p:txBody>
+          <a:bodyPr wrap="square" lIns="0" rIns="0" tIns="0" bIns="0" anchor="t">
+            <a:spAutoFit/>
+          </a:bodyPr>
+          <a:lstStyle/>
+          <a:p>
+            <a:pPr algn="l">
+              <a:lnSpc>
+                <a:spcPct val="128000"/>
+              </a:lnSpc>
+              <a:spcBef>
+                <a:spcPts val="0"/>
+              </a:spcBef>
+              <a:spcAft>
+                <a:spcPts val="0"/>
+              </a:spcAft>
+            </a:pPr>
+            <a:r>
+              <a:rPr sz="1050" b="0" i="0">
+                <a:solidFill>
+                  <a:srgbClr val="1A1A1A"/>
+                </a:solidFill>
+                <a:latin typeface="Calibri"/>
+              </a:rPr>
+              <a:t>Same record, plus who is at MoU stage rather than already committed</a:t>
+            </a:r>
+          </a:p>
+        </p:txBody>
+      </p:sp>
+      <p:sp>
+        <p:nvSpPr>
+          <p:cNvPr id="19" name="Rectangle 18"/>
           <p:cNvSpPr/>
           <p:nvPr/>
         </p:nvSpPr>
         <p:spPr>
           <a:xfrm>
-            <a:off x="713232" y="3968496"/>
-            <a:ext cx="33020" cy="658368"/>
+            <a:off x="10003536" y="3191256"/>
+            <a:ext cx="1371600" cy="237744"/>
           </a:xfrm>
           <a:prstGeom prst="rect">
             <a:avLst/>
           </a:prstGeom>
           <a:solidFill>
-            <a:srgbClr val="7A5618"/>
+            <a:srgbClr val="E8F1ED"/>
           </a:solidFill>
           <a:ln>
             <a:noFill/>
@@ -8491,23 +8817,32 @@
           </a:fontRef>
         </p:style>
         <p:txBody>
-          <a:bodyPr rtlCol="0" anchor="ctr"/>
+          <a:bodyPr rtlCol="0" anchor="ctr" lIns="64008" rIns="64008" tIns="0" bIns="0"/>
           <a:lstStyle/>
           <a:p>
             <a:pPr algn="ctr"/>
-          </a:p>
-        </p:txBody>
-      </p:sp>
-      <p:sp>
-        <p:nvSpPr>
-          <p:cNvPr id="12" name="TextBox 11"/>
-          <p:cNvSpPr txBox="1"/>
-          <p:nvPr/>
-        </p:nvSpPr>
-        <p:spPr>
-          <a:xfrm>
-            <a:off x="914400" y="3968496"/>
-            <a:ext cx="10564063" cy="658368"/>
+            <a:r>
+              <a:rPr sz="950" b="1">
+                <a:solidFill>
+                  <a:srgbClr val="1D5C43"/>
+                </a:solidFill>
+                <a:latin typeface="Calibri"/>
+              </a:rPr>
+              <a:t>Serving now</a:t>
+            </a:r>
+          </a:p>
+        </p:txBody>
+      </p:sp>
+      <p:sp>
+        <p:nvSpPr>
+          <p:cNvPr id="20" name="TextBox 19"/>
+          <p:cNvSpPr txBox="1"/>
+          <p:nvPr/>
+        </p:nvSpPr>
+        <p:spPr>
+          <a:xfrm>
+            <a:off x="713232" y="3712464"/>
+            <a:ext cx="2286000" cy="548640"/>
           </a:xfrm>
           <a:prstGeom prst="rect">
             <a:avLst/>
@@ -8522,65 +8857,133 @@
           <a:p>
             <a:pPr algn="l">
               <a:lnSpc>
-                <a:spcPct val="135000"/>
-              </a:lnSpc>
-              <a:spcBef>
-                <a:spcPts val="0"/>
-              </a:spcBef>
-              <a:spcAft>
-                <a:spcPts val="300"/>
-              </a:spcAft>
-            </a:pPr>
-            <a:r>
-              <a:rPr sz="1250" b="1" i="0">
+                <a:spcPct val="125000"/>
+              </a:lnSpc>
+              <a:spcBef>
+                <a:spcPts val="0"/>
+              </a:spcBef>
+              <a:spcAft>
+                <a:spcPts val="0"/>
+              </a:spcAft>
+            </a:pPr>
+            <a:r>
+              <a:rPr sz="1100" b="1" i="0">
                 <a:solidFill>
                   <a:srgbClr val="1A1A1A"/>
                 </a:solidFill>
                 <a:latin typeface="Calibri"/>
               </a:rPr>
-              <a:t>20 records is a sample, not a market</a:t>
-            </a:r>
-          </a:p>
-          <a:p>
-            <a:pPr>
-              <a:lnSpc>
-                <a:spcPct val="133000"/>
-              </a:lnSpc>
-              <a:spcBef>
-                <a:spcPts val="0"/>
-              </a:spcBef>
-              <a:spcAft>
-                <a:spcPts val="600"/>
-              </a:spcAft>
-            </a:pPr>
-            <a:r>
-              <a:rPr sz="1100" b="0" i="0">
-                <a:solidFill>
-                  <a:srgbClr val="4A4845"/>
-                </a:solidFill>
-                <a:latin typeface="Calibri"/>
-              </a:rPr>
-              <a:t>Coverage is skewed toward cities and states with active press communications. A count here measures reporting volume, not real activity.</a:t>
-            </a:r>
-          </a:p>
-        </p:txBody>
-      </p:sp>
-      <p:sp>
-        <p:nvSpPr>
-          <p:cNvPr id="13" name="Rectangle 12"/>
+              <a:t>Real estate firms</a:t>
+            </a:r>
+          </a:p>
+        </p:txBody>
+      </p:sp>
+      <p:sp>
+        <p:nvSpPr>
+          <p:cNvPr id="21" name="TextBox 20"/>
+          <p:cNvSpPr txBox="1"/>
+          <p:nvPr/>
+        </p:nvSpPr>
+        <p:spPr>
+          <a:xfrm>
+            <a:off x="3108960" y="3712464"/>
+            <a:ext cx="2743200" cy="548640"/>
+          </a:xfrm>
+          <a:prstGeom prst="rect">
+            <a:avLst/>
+          </a:prstGeom>
+          <a:noFill/>
+        </p:spPr>
+        <p:txBody>
+          <a:bodyPr wrap="square" lIns="0" rIns="0" tIns="0" bIns="0" anchor="t">
+            <a:spAutoFit/>
+          </a:bodyPr>
+          <a:lstStyle/>
+          <a:p>
+            <a:pPr algn="l">
+              <a:lnSpc>
+                <a:spcPct val="128000"/>
+              </a:lnSpc>
+              <a:spcBef>
+                <a:spcPts val="0"/>
+              </a:spcBef>
+              <a:spcAft>
+                <a:spcPts val="0"/>
+              </a:spcAft>
+            </a:pPr>
+            <a:r>
+              <a:rPr sz="1050" b="0" i="0">
+                <a:solidFill>
+                  <a:srgbClr val="7A7772"/>
+                </a:solidFill>
+                <a:latin typeface="Calibri"/>
+              </a:rPr>
+              <a:t>Leasing data they already hold</a:t>
+            </a:r>
+          </a:p>
+        </p:txBody>
+      </p:sp>
+      <p:sp>
+        <p:nvSpPr>
+          <p:cNvPr id="22" name="TextBox 21"/>
+          <p:cNvSpPr txBox="1"/>
+          <p:nvPr/>
+        </p:nvSpPr>
+        <p:spPr>
+          <a:xfrm>
+            <a:off x="5961888" y="3712464"/>
+            <a:ext cx="3931920" cy="548640"/>
+          </a:xfrm>
+          <a:prstGeom prst="rect">
+            <a:avLst/>
+          </a:prstGeom>
+          <a:noFill/>
+        </p:spPr>
+        <p:txBody>
+          <a:bodyPr wrap="square" lIns="0" rIns="0" tIns="0" bIns="0" anchor="t">
+            <a:spAutoFit/>
+          </a:bodyPr>
+          <a:lstStyle/>
+          <a:p>
+            <a:pPr algn="l">
+              <a:lnSpc>
+                <a:spcPct val="128000"/>
+              </a:lnSpc>
+              <a:spcBef>
+                <a:spcPts val="0"/>
+              </a:spcBef>
+              <a:spcAft>
+                <a:spcPts val="0"/>
+              </a:spcAft>
+            </a:pPr>
+            <a:r>
+              <a:rPr sz="1050" b="0" i="0">
+                <a:solidFill>
+                  <a:srgbClr val="1A1A1A"/>
+                </a:solidFill>
+                <a:latin typeface="Calibri"/>
+              </a:rPr>
+              <a:t>The reverse view — intent signals that precede a space requirement</a:t>
+            </a:r>
+          </a:p>
+        </p:txBody>
+      </p:sp>
+      <p:sp>
+        <p:nvSpPr>
+          <p:cNvPr id="23" name="Rectangle 22"/>
           <p:cNvSpPr/>
           <p:nvPr/>
         </p:nvSpPr>
         <p:spPr>
           <a:xfrm>
-            <a:off x="713232" y="4754880"/>
-            <a:ext cx="33020" cy="658368"/>
+            <a:off x="10003536" y="3694176"/>
+            <a:ext cx="1371600" cy="237744"/>
           </a:xfrm>
           <a:prstGeom prst="rect">
             <a:avLst/>
           </a:prstGeom>
           <a:solidFill>
-            <a:srgbClr val="7A5618"/>
+            <a:srgbClr val="E8F1ED"/>
           </a:solidFill>
           <a:ln>
             <a:noFill/>
@@ -8602,23 +9005,32 @@
           </a:fontRef>
         </p:style>
         <p:txBody>
-          <a:bodyPr rtlCol="0" anchor="ctr"/>
+          <a:bodyPr rtlCol="0" anchor="ctr" lIns="64008" rIns="64008" tIns="0" bIns="0"/>
           <a:lstStyle/>
           <a:p>
             <a:pPr algn="ctr"/>
-          </a:p>
-        </p:txBody>
-      </p:sp>
-      <p:sp>
-        <p:nvSpPr>
-          <p:cNvPr id="14" name="TextBox 13"/>
-          <p:cNvSpPr txBox="1"/>
-          <p:nvPr/>
-        </p:nvSpPr>
-        <p:spPr>
-          <a:xfrm>
-            <a:off x="914400" y="4754880"/>
-            <a:ext cx="10564063" cy="658368"/>
+            <a:r>
+              <a:rPr sz="950" b="1">
+                <a:solidFill>
+                  <a:srgbClr val="1D5C43"/>
+                </a:solidFill>
+                <a:latin typeface="Calibri"/>
+              </a:rPr>
+              <a:t>Mostly today</a:t>
+            </a:r>
+          </a:p>
+        </p:txBody>
+      </p:sp>
+      <p:sp>
+        <p:nvSpPr>
+          <p:cNvPr id="24" name="TextBox 23"/>
+          <p:cNvSpPr txBox="1"/>
+          <p:nvPr/>
+        </p:nvSpPr>
+        <p:spPr>
+          <a:xfrm>
+            <a:off x="713232" y="4215384"/>
+            <a:ext cx="2286000" cy="548640"/>
           </a:xfrm>
           <a:prstGeom prst="rect">
             <a:avLst/>
@@ -8633,65 +9045,133 @@
           <a:p>
             <a:pPr algn="l">
               <a:lnSpc>
-                <a:spcPct val="135000"/>
-              </a:lnSpc>
-              <a:spcBef>
-                <a:spcPts val="0"/>
-              </a:spcBef>
-              <a:spcAft>
-                <a:spcPts val="300"/>
-              </a:spcAft>
-            </a:pPr>
-            <a:r>
-              <a:rPr sz="1250" b="1" i="0">
+                <a:spcPct val="125000"/>
+              </a:lnSpc>
+              <a:spcBef>
+                <a:spcPts val="0"/>
+              </a:spcBef>
+              <a:spcAft>
+                <a:spcPts val="0"/>
+              </a:spcAft>
+            </a:pPr>
+            <a:r>
+              <a:rPr sz="1100" b="1" i="0">
                 <a:solidFill>
                   <a:srgbClr val="1A1A1A"/>
                 </a:solidFill>
                 <a:latin typeface="Calibri"/>
               </a:rPr>
-              <a:t>It cannot predict, and does not try</a:t>
-            </a:r>
-          </a:p>
-          <a:p>
-            <a:pPr>
-              <a:lnSpc>
-                <a:spcPct val="133000"/>
-              </a:lnSpc>
-              <a:spcBef>
-                <a:spcPts val="0"/>
-              </a:spcBef>
-              <a:spcAft>
-                <a:spcPts val="600"/>
-              </a:spcAft>
-            </a:pPr>
-            <a:r>
-              <a:rPr sz="1100" b="0" i="0">
-                <a:solidFill>
-                  <a:srgbClr val="4A4845"/>
-                </a:solidFill>
-                <a:latin typeface="Calibri"/>
-              </a:rPr>
-              <a:t>I looked for evidence that public signals give reliable early warning of GCC setups. I did not find enough to support that claim, so the product does not make it.</a:t>
-            </a:r>
-          </a:p>
-        </p:txBody>
-      </p:sp>
-      <p:sp>
-        <p:nvSpPr>
-          <p:cNvPr id="15" name="Rectangle 14"/>
+              <a:t>State promotion agencies</a:t>
+            </a:r>
+          </a:p>
+        </p:txBody>
+      </p:sp>
+      <p:sp>
+        <p:nvSpPr>
+          <p:cNvPr id="25" name="TextBox 24"/>
+          <p:cNvSpPr txBox="1"/>
+          <p:nvPr/>
+        </p:nvSpPr>
+        <p:spPr>
+          <a:xfrm>
+            <a:off x="3108960" y="4215384"/>
+            <a:ext cx="2743200" cy="548640"/>
+          </a:xfrm>
+          <a:prstGeom prst="rect">
+            <a:avLst/>
+          </a:prstGeom>
+          <a:noFill/>
+        </p:spPr>
+        <p:txBody>
+          <a:bodyPr wrap="square" lIns="0" rIns="0" tIns="0" bIns="0" anchor="t">
+            <a:spAutoFit/>
+          </a:bodyPr>
+          <a:lstStyle/>
+          <a:p>
+            <a:pPr algn="l">
+              <a:lnSpc>
+                <a:spcPct val="128000"/>
+              </a:lnSpc>
+              <a:spcBef>
+                <a:spcPts val="0"/>
+              </a:spcBef>
+              <a:spcAft>
+                <a:spcPts val="0"/>
+              </a:spcAft>
+            </a:pPr>
+            <a:r>
+              <a:rPr sz="1050" b="0" i="0">
+                <a:solidFill>
+                  <a:srgbClr val="7A7772"/>
+                </a:solidFill>
+                <a:latin typeface="Calibri"/>
+              </a:rPr>
+              <a:t>Their own pipeline; press monitoring</a:t>
+            </a:r>
+          </a:p>
+        </p:txBody>
+      </p:sp>
+      <p:sp>
+        <p:nvSpPr>
+          <p:cNvPr id="26" name="TextBox 25"/>
+          <p:cNvSpPr txBox="1"/>
+          <p:nvPr/>
+        </p:nvSpPr>
+        <p:spPr>
+          <a:xfrm>
+            <a:off x="5961888" y="4215384"/>
+            <a:ext cx="3931920" cy="548640"/>
+          </a:xfrm>
+          <a:prstGeom prst="rect">
+            <a:avLst/>
+          </a:prstGeom>
+          <a:noFill/>
+        </p:spPr>
+        <p:txBody>
+          <a:bodyPr wrap="square" lIns="0" rIns="0" tIns="0" bIns="0" anchor="t">
+            <a:spAutoFit/>
+          </a:bodyPr>
+          <a:lstStyle/>
+          <a:p>
+            <a:pPr algn="l">
+              <a:lnSpc>
+                <a:spcPct val="128000"/>
+              </a:lnSpc>
+              <a:spcBef>
+                <a:spcPts val="0"/>
+              </a:spcBef>
+              <a:spcAft>
+                <a:spcPts val="0"/>
+              </a:spcAft>
+            </a:pPr>
+            <a:r>
+              <a:rPr sz="1050" b="0" i="0">
+                <a:solidFill>
+                  <a:srgbClr val="1A1A1A"/>
+                </a:solidFill>
+                <a:latin typeface="Calibri"/>
+              </a:rPr>
+              <a:t>A neutral record of what peer states are winning, with sources</a:t>
+            </a:r>
+          </a:p>
+        </p:txBody>
+      </p:sp>
+      <p:sp>
+        <p:nvSpPr>
+          <p:cNvPr id="27" name="Rectangle 26"/>
           <p:cNvSpPr/>
           <p:nvPr/>
         </p:nvSpPr>
         <p:spPr>
           <a:xfrm>
-            <a:off x="713232" y="5541264"/>
-            <a:ext cx="33020" cy="658368"/>
+            <a:off x="10003536" y="4197096"/>
+            <a:ext cx="1371600" cy="237744"/>
           </a:xfrm>
           <a:prstGeom prst="rect">
             <a:avLst/>
           </a:prstGeom>
           <a:solidFill>
-            <a:srgbClr val="7A5618"/>
+            <a:srgbClr val="F7F0E2"/>
           </a:solidFill>
           <a:ln>
             <a:noFill/>
@@ -8713,6 +9193,437 @@
           </a:fontRef>
         </p:style>
         <p:txBody>
+          <a:bodyPr rtlCol="0" anchor="ctr" lIns="64008" rIns="64008" tIns="0" bIns="0"/>
+          <a:lstStyle/>
+          <a:p>
+            <a:pPr algn="ctr"/>
+            <a:r>
+              <a:rPr sz="950" b="1">
+                <a:solidFill>
+                  <a:srgbClr val="7A5618"/>
+                </a:solidFill>
+                <a:latin typeface="Calibri"/>
+              </a:rPr>
+              <a:t>Needs coverage</a:t>
+            </a:r>
+          </a:p>
+        </p:txBody>
+      </p:sp>
+      <p:sp>
+        <p:nvSpPr>
+          <p:cNvPr id="28" name="TextBox 27"/>
+          <p:cNvSpPr txBox="1"/>
+          <p:nvPr/>
+        </p:nvSpPr>
+        <p:spPr>
+          <a:xfrm>
+            <a:off x="713232" y="4718304"/>
+            <a:ext cx="2286000" cy="548640"/>
+          </a:xfrm>
+          <a:prstGeom prst="rect">
+            <a:avLst/>
+          </a:prstGeom>
+          <a:noFill/>
+        </p:spPr>
+        <p:txBody>
+          <a:bodyPr wrap="square" lIns="0" rIns="0" tIns="0" bIns="0" anchor="t">
+            <a:spAutoFit/>
+          </a:bodyPr>
+          <a:lstStyle/>
+          <a:p>
+            <a:pPr algn="l">
+              <a:lnSpc>
+                <a:spcPct val="125000"/>
+              </a:lnSpc>
+              <a:spcBef>
+                <a:spcPts val="0"/>
+              </a:spcBef>
+              <a:spcAft>
+                <a:spcPts val="0"/>
+              </a:spcAft>
+            </a:pPr>
+            <a:r>
+              <a:rPr sz="1100" b="1" i="0">
+                <a:solidFill>
+                  <a:srgbClr val="1A1A1A"/>
+                </a:solidFill>
+                <a:latin typeface="Calibri"/>
+              </a:rPr>
+              <a:t>Companies setting up a GCC</a:t>
+            </a:r>
+          </a:p>
+        </p:txBody>
+      </p:sp>
+      <p:sp>
+        <p:nvSpPr>
+          <p:cNvPr id="29" name="TextBox 28"/>
+          <p:cNvSpPr txBox="1"/>
+          <p:nvPr/>
+        </p:nvSpPr>
+        <p:spPr>
+          <a:xfrm>
+            <a:off x="3108960" y="4718304"/>
+            <a:ext cx="2743200" cy="548640"/>
+          </a:xfrm>
+          <a:prstGeom prst="rect">
+            <a:avLst/>
+          </a:prstGeom>
+          <a:noFill/>
+        </p:spPr>
+        <p:txBody>
+          <a:bodyPr wrap="square" lIns="0" rIns="0" tIns="0" bIns="0" anchor="t">
+            <a:spAutoFit/>
+          </a:bodyPr>
+          <a:lstStyle/>
+          <a:p>
+            <a:pPr algn="l">
+              <a:lnSpc>
+                <a:spcPct val="128000"/>
+              </a:lnSpc>
+              <a:spcBef>
+                <a:spcPts val="0"/>
+              </a:spcBef>
+              <a:spcAft>
+                <a:spcPts val="0"/>
+              </a:spcAft>
+            </a:pPr>
+            <a:r>
+              <a:rPr sz="1050" b="0" i="0">
+                <a:solidFill>
+                  <a:srgbClr val="7A7772"/>
+                </a:solidFill>
+                <a:latin typeface="Calibri"/>
+              </a:rPr>
+              <a:t>Advisors, who are themselves conflicted</a:t>
+            </a:r>
+          </a:p>
+        </p:txBody>
+      </p:sp>
+      <p:sp>
+        <p:nvSpPr>
+          <p:cNvPr id="30" name="TextBox 29"/>
+          <p:cNvSpPr txBox="1"/>
+          <p:nvPr/>
+        </p:nvSpPr>
+        <p:spPr>
+          <a:xfrm>
+            <a:off x="5961888" y="4718304"/>
+            <a:ext cx="3931920" cy="548640"/>
+          </a:xfrm>
+          <a:prstGeom prst="rect">
+            <a:avLst/>
+          </a:prstGeom>
+          <a:noFill/>
+        </p:spPr>
+        <p:txBody>
+          <a:bodyPr wrap="square" lIns="0" rIns="0" tIns="0" bIns="0" anchor="t">
+            <a:spAutoFit/>
+          </a:bodyPr>
+          <a:lstStyle/>
+          <a:p>
+            <a:pPr algn="l">
+              <a:lnSpc>
+                <a:spcPct val="128000"/>
+              </a:lnSpc>
+              <a:spcBef>
+                <a:spcPts val="0"/>
+              </a:spcBef>
+              <a:spcAft>
+                <a:spcPts val="0"/>
+              </a:spcAft>
+            </a:pPr>
+            <a:r>
+              <a:rPr sz="1050" b="0" i="0">
+                <a:solidFill>
+                  <a:srgbClr val="1A1A1A"/>
+                </a:solidFill>
+                <a:latin typeface="Calibri"/>
+              </a:rPr>
+              <a:t>Verified cost, incentive and provider data — none of which I hold</a:t>
+            </a:r>
+          </a:p>
+        </p:txBody>
+      </p:sp>
+      <p:sp>
+        <p:nvSpPr>
+          <p:cNvPr id="31" name="Rectangle 30"/>
+          <p:cNvSpPr/>
+          <p:nvPr/>
+        </p:nvSpPr>
+        <p:spPr>
+          <a:xfrm>
+            <a:off x="10003536" y="4700016"/>
+            <a:ext cx="1371600" cy="237744"/>
+          </a:xfrm>
+          <a:prstGeom prst="rect">
+            <a:avLst/>
+          </a:prstGeom>
+          <a:solidFill>
+            <a:srgbClr val="F8ECEB"/>
+          </a:solidFill>
+          <a:ln>
+            <a:noFill/>
+          </a:ln>
+          <a:effectLst/>
+        </p:spPr>
+        <p:style>
+          <a:lnRef idx="1">
+            <a:schemeClr val="accent1"/>
+          </a:lnRef>
+          <a:fillRef idx="3">
+            <a:schemeClr val="accent1"/>
+          </a:fillRef>
+          <a:effectRef idx="2">
+            <a:schemeClr val="accent1"/>
+          </a:effectRef>
+          <a:fontRef idx="minor">
+            <a:schemeClr val="lt1"/>
+          </a:fontRef>
+        </p:style>
+        <p:txBody>
+          <a:bodyPr rtlCol="0" anchor="ctr" lIns="64008" rIns="64008" tIns="0" bIns="0"/>
+          <a:lstStyle/>
+          <a:p>
+            <a:pPr algn="ctr"/>
+            <a:r>
+              <a:rPr sz="950" b="1">
+                <a:solidFill>
+                  <a:srgbClr val="7D3B36"/>
+                </a:solidFill>
+                <a:latin typeface="Calibri"/>
+              </a:rPr>
+              <a:t>Not yet</a:t>
+            </a:r>
+          </a:p>
+        </p:txBody>
+      </p:sp>
+      <p:sp>
+        <p:nvSpPr>
+          <p:cNvPr id="32" name="TextBox 31"/>
+          <p:cNvSpPr txBox="1"/>
+          <p:nvPr/>
+        </p:nvSpPr>
+        <p:spPr>
+          <a:xfrm>
+            <a:off x="713232" y="5221224"/>
+            <a:ext cx="2286000" cy="548640"/>
+          </a:xfrm>
+          <a:prstGeom prst="rect">
+            <a:avLst/>
+          </a:prstGeom>
+          <a:noFill/>
+        </p:spPr>
+        <p:txBody>
+          <a:bodyPr wrap="square" lIns="0" rIns="0" tIns="0" bIns="0" anchor="t">
+            <a:spAutoFit/>
+          </a:bodyPr>
+          <a:lstStyle/>
+          <a:p>
+            <a:pPr algn="l">
+              <a:lnSpc>
+                <a:spcPct val="125000"/>
+              </a:lnSpc>
+              <a:spcBef>
+                <a:spcPts val="0"/>
+              </a:spcBef>
+              <a:spcAft>
+                <a:spcPts val="0"/>
+              </a:spcAft>
+            </a:pPr>
+            <a:r>
+              <a:rPr sz="1100" b="1" i="0">
+                <a:solidFill>
+                  <a:srgbClr val="1A1A1A"/>
+                </a:solidFill>
+                <a:latin typeface="Calibri"/>
+              </a:rPr>
+              <a:t>EOR &amp; legal providers</a:t>
+            </a:r>
+          </a:p>
+        </p:txBody>
+      </p:sp>
+      <p:sp>
+        <p:nvSpPr>
+          <p:cNvPr id="33" name="TextBox 32"/>
+          <p:cNvSpPr txBox="1"/>
+          <p:nvPr/>
+        </p:nvSpPr>
+        <p:spPr>
+          <a:xfrm>
+            <a:off x="3108960" y="5221224"/>
+            <a:ext cx="2743200" cy="548640"/>
+          </a:xfrm>
+          <a:prstGeom prst="rect">
+            <a:avLst/>
+          </a:prstGeom>
+          <a:noFill/>
+        </p:spPr>
+        <p:txBody>
+          <a:bodyPr wrap="square" lIns="0" rIns="0" tIns="0" bIns="0" anchor="t">
+            <a:spAutoFit/>
+          </a:bodyPr>
+          <a:lstStyle/>
+          <a:p>
+            <a:pPr algn="l">
+              <a:lnSpc>
+                <a:spcPct val="128000"/>
+              </a:lnSpc>
+              <a:spcBef>
+                <a:spcPts val="0"/>
+              </a:spcBef>
+              <a:spcAft>
+                <a:spcPts val="0"/>
+              </a:spcAft>
+            </a:pPr>
+            <a:r>
+              <a:rPr sz="1050" b="0" i="0">
+                <a:solidFill>
+                  <a:srgbClr val="7A7772"/>
+                </a:solidFill>
+                <a:latin typeface="Calibri"/>
+              </a:rPr>
+              <a:t>Referrals</a:t>
+            </a:r>
+          </a:p>
+        </p:txBody>
+      </p:sp>
+      <p:sp>
+        <p:nvSpPr>
+          <p:cNvPr id="34" name="TextBox 33"/>
+          <p:cNvSpPr txBox="1"/>
+          <p:nvPr/>
+        </p:nvSpPr>
+        <p:spPr>
+          <a:xfrm>
+            <a:off x="5961888" y="5221224"/>
+            <a:ext cx="3931920" cy="548640"/>
+          </a:xfrm>
+          <a:prstGeom prst="rect">
+            <a:avLst/>
+          </a:prstGeom>
+          <a:noFill/>
+        </p:spPr>
+        <p:txBody>
+          <a:bodyPr wrap="square" lIns="0" rIns="0" tIns="0" bIns="0" anchor="t">
+            <a:spAutoFit/>
+          </a:bodyPr>
+          <a:lstStyle/>
+          <a:p>
+            <a:pPr algn="l">
+              <a:lnSpc>
+                <a:spcPct val="128000"/>
+              </a:lnSpc>
+              <a:spcBef>
+                <a:spcPts val="0"/>
+              </a:spcBef>
+              <a:spcAft>
+                <a:spcPts val="0"/>
+              </a:spcAft>
+            </a:pPr>
+            <a:r>
+              <a:rPr sz="1050" b="0" i="0">
+                <a:solidFill>
+                  <a:srgbClr val="1A1A1A"/>
+                </a:solidFill>
+                <a:latin typeface="Calibri"/>
+              </a:rPr>
+              <a:t>Entity-level data tying each centre to its Indian legal entity</a:t>
+            </a:r>
+          </a:p>
+        </p:txBody>
+      </p:sp>
+      <p:sp>
+        <p:nvSpPr>
+          <p:cNvPr id="35" name="Rectangle 34"/>
+          <p:cNvSpPr/>
+          <p:nvPr/>
+        </p:nvSpPr>
+        <p:spPr>
+          <a:xfrm>
+            <a:off x="10003536" y="5202936"/>
+            <a:ext cx="1371600" cy="237744"/>
+          </a:xfrm>
+          <a:prstGeom prst="rect">
+            <a:avLst/>
+          </a:prstGeom>
+          <a:solidFill>
+            <a:srgbClr val="F8ECEB"/>
+          </a:solidFill>
+          <a:ln>
+            <a:noFill/>
+          </a:ln>
+          <a:effectLst/>
+        </p:spPr>
+        <p:style>
+          <a:lnRef idx="1">
+            <a:schemeClr val="accent1"/>
+          </a:lnRef>
+          <a:fillRef idx="3">
+            <a:schemeClr val="accent1"/>
+          </a:fillRef>
+          <a:effectRef idx="2">
+            <a:schemeClr val="accent1"/>
+          </a:effectRef>
+          <a:fontRef idx="minor">
+            <a:schemeClr val="lt1"/>
+          </a:fontRef>
+        </p:style>
+        <p:txBody>
+          <a:bodyPr rtlCol="0" anchor="ctr" lIns="64008" rIns="64008" tIns="0" bIns="0"/>
+          <a:lstStyle/>
+          <a:p>
+            <a:pPr algn="ctr"/>
+            <a:r>
+              <a:rPr sz="950" b="1">
+                <a:solidFill>
+                  <a:srgbClr val="7D3B36"/>
+                </a:solidFill>
+                <a:latin typeface="Calibri"/>
+              </a:rPr>
+              <a:t>Not yet</a:t>
+            </a:r>
+          </a:p>
+        </p:txBody>
+      </p:sp>
+      <p:sp>
+        <p:nvSpPr>
+          <p:cNvPr id="36" name="Rectangle 35"/>
+          <p:cNvSpPr/>
+          <p:nvPr/>
+        </p:nvSpPr>
+        <p:spPr>
+          <a:xfrm>
+            <a:off x="713232" y="5724144"/>
+            <a:ext cx="10765231" cy="603504"/>
+          </a:xfrm>
+          <a:prstGeom prst="rect">
+            <a:avLst/>
+          </a:prstGeom>
+          <a:solidFill>
+            <a:srgbClr val="F7F0E2"/>
+          </a:solidFill>
+          <a:ln w="11430">
+            <a:solidFill>
+              <a:srgbClr val="E6D7B6"/>
+            </a:solidFill>
+          </a:ln>
+          <a:effectLst/>
+        </p:spPr>
+        <p:style>
+          <a:lnRef idx="1">
+            <a:schemeClr val="accent1"/>
+          </a:lnRef>
+          <a:fillRef idx="3">
+            <a:schemeClr val="accent1"/>
+          </a:fillRef>
+          <a:effectRef idx="2">
+            <a:schemeClr val="accent1"/>
+          </a:effectRef>
+          <a:fontRef idx="minor">
+            <a:schemeClr val="lt1"/>
+          </a:fontRef>
+        </p:style>
+        <p:txBody>
           <a:bodyPr rtlCol="0" anchor="ctr"/>
           <a:lstStyle/>
           <a:p>
@@ -8722,14 +9633,14 @@
       </p:sp>
       <p:sp>
         <p:nvSpPr>
-          <p:cNvPr id="16" name="TextBox 15"/>
-          <p:cNvSpPr txBox="1"/>
-          <p:nvPr/>
-        </p:nvSpPr>
-        <p:spPr>
-          <a:xfrm>
-            <a:off x="914400" y="5541264"/>
-            <a:ext cx="10564063" cy="658368"/>
+          <p:cNvPr id="37" name="TextBox 36"/>
+          <p:cNvSpPr txBox="1"/>
+          <p:nvPr/>
+        </p:nvSpPr>
+        <p:spPr>
+          <a:xfrm>
+            <a:off x="914400" y="5833872"/>
+            <a:ext cx="10362895" cy="420624"/>
           </a:xfrm>
           <a:prstGeom prst="rect">
             <a:avLst/>
@@ -8744,52 +9655,36 @@
           <a:p>
             <a:pPr algn="l">
               <a:lnSpc>
-                <a:spcPct val="135000"/>
-              </a:lnSpc>
-              <a:spcBef>
-                <a:spcPts val="0"/>
-              </a:spcBef>
-              <a:spcAft>
-                <a:spcPts val="300"/>
-              </a:spcAft>
-            </a:pPr>
-            <a:r>
-              <a:rPr sz="1250" b="1" i="0">
-                <a:solidFill>
-                  <a:srgbClr val="1A1A1A"/>
-                </a:solidFill>
-                <a:latin typeface="Calibri"/>
-              </a:rPr>
-              <a:t>"Ask" is keyword search, not AI</a:t>
-            </a:r>
-          </a:p>
-          <a:p>
-            <a:pPr>
-              <a:lnSpc>
-                <a:spcPct val="133000"/>
-              </a:lnSpc>
-              <a:spcBef>
-                <a:spcPts val="0"/>
-              </a:spcBef>
+                <a:spcPct val="130000"/>
+              </a:lnSpc>
               <a:spcAft>
                 <a:spcPts val="600"/>
               </a:spcAft>
             </a:pPr>
             <a:r>
-              <a:rPr sz="1100" b="0" i="0">
+              <a:rPr sz="1100" b="1">
+                <a:solidFill>
+                  <a:srgbClr val="7A5618"/>
+                </a:solidFill>
+                <a:latin typeface="Calibri"/>
+              </a:rPr>
+              <a:t>On sizing the problem: </a:t>
+            </a:r>
+            <a:r>
+              <a:rPr sz="1100" b="0">
                 <a:solidFill>
                   <a:srgbClr val="4A4845"/>
                 </a:solidFill>
                 <a:latin typeface="Calibri"/>
               </a:rPr>
-              <a:t>It scores records by word overlap and detects a few patterns. The app says so on the page itself. No model, no API key, no cost.</a:t>
-            </a:r>
-          </a:p>
-        </p:txBody>
-      </p:sp>
-      <p:sp>
-        <p:nvSpPr>
-          <p:cNvPr id="17" name="TextBox 16"/>
+              <a:t>I could not find a credible public figure for what this asymmetry costs, and I will not invent one. Measuring it means asking firms how many opportunities they learn about too late — the first thing I would test.</a:t>
+            </a:r>
+          </a:p>
+        </p:txBody>
+      </p:sp>
+      <p:sp>
+        <p:nvSpPr>
+          <p:cNvPr id="38" name="TextBox 37"/>
           <p:cNvSpPr txBox="1"/>
           <p:nvPr/>
         </p:nvSpPr>
@@ -8833,14 +9728,14 @@
                 </a:solidFill>
                 <a:latin typeface="Calibri"/>
               </a:rPr>
-              <a:t>   ·   Limitations &amp; assumptions</a:t>
-            </a:r>
-          </a:p>
-        </p:txBody>
-      </p:sp>
-      <p:sp>
-        <p:nvSpPr>
-          <p:cNvPr id="18" name="TextBox 17"/>
+              <a:t>   ·   Positioning · Other stakeholders</a:t>
+            </a:r>
+          </a:p>
+        </p:txBody>
+      </p:sp>
+      <p:sp>
+        <p:nvSpPr>
+          <p:cNvPr id="39" name="TextBox 38"/>
           <p:cNvSpPr txBox="1"/>
           <p:nvPr/>
         </p:nvSpPr>
@@ -8985,7 +9880,7 @@
                 </a:solidFill>
                 <a:latin typeface="Calibri"/>
               </a:rPr>
-              <a:t>NEXT</a:t>
+              <a:t>HONESTY</a:t>
             </a:r>
           </a:p>
         </p:txBody>
@@ -9030,20 +9925,65 @@
                 </a:solidFill>
                 <a:latin typeface="Georgia"/>
               </a:rPr>
-              <a:t>What I would do next, in order</a:t>
-            </a:r>
-          </a:p>
-        </p:txBody>
-      </p:sp>
-      <p:sp>
-        <p:nvSpPr>
-          <p:cNvPr id="5" name="Rectangle 4"/>
+              <a:t>What is not true about this yet</a:t>
+            </a:r>
+          </a:p>
+        </p:txBody>
+      </p:sp>
+      <p:sp>
+        <p:nvSpPr>
+          <p:cNvPr id="5" name="TextBox 4"/>
+          <p:cNvSpPr txBox="1"/>
+          <p:nvPr/>
+        </p:nvSpPr>
+        <p:spPr>
+          <a:xfrm>
+            <a:off x="713232" y="1517904"/>
+            <a:ext cx="8778240" cy="640080"/>
+          </a:xfrm>
+          <a:prstGeom prst="rect">
+            <a:avLst/>
+          </a:prstGeom>
+          <a:noFill/>
+        </p:spPr>
+        <p:txBody>
+          <a:bodyPr wrap="square" lIns="0" rIns="0" tIns="0" bIns="0" anchor="t">
+            <a:spAutoFit/>
+          </a:bodyPr>
+          <a:lstStyle/>
+          <a:p>
+            <a:pPr algn="l">
+              <a:lnSpc>
+                <a:spcPct val="140000"/>
+              </a:lnSpc>
+              <a:spcBef>
+                <a:spcPts val="0"/>
+              </a:spcBef>
+              <a:spcAft>
+                <a:spcPts val="0"/>
+              </a:spcAft>
+            </a:pPr>
+            <a:r>
+              <a:rPr sz="1450" b="0" i="0">
+                <a:solidFill>
+                  <a:srgbClr val="4A4845"/>
+                </a:solidFill>
+                <a:latin typeface="Calibri"/>
+              </a:rPr>
+              <a:t>Stated here rather than discovered later. The product repeats all of this on its own Sources &amp; Method page.</a:t>
+            </a:r>
+          </a:p>
+        </p:txBody>
+      </p:sp>
+      <p:sp>
+        <p:nvSpPr>
+          <p:cNvPr id="6" name="Rectangle 5"/>
           <p:cNvSpPr/>
           <p:nvPr/>
         </p:nvSpPr>
         <p:spPr>
           <a:xfrm>
-            <a:off x="713232" y="1426464"/>
+            <a:off x="713232" y="2121408"/>
             <a:ext cx="10765231" cy="11430"/>
           </a:xfrm>
           <a:prstGeom prst="rect">
@@ -9081,20 +10021,20 @@
       </p:sp>
       <p:sp>
         <p:nvSpPr>
-          <p:cNvPr id="6" name="Oval 5"/>
+          <p:cNvPr id="7" name="Rectangle 6"/>
           <p:cNvSpPr/>
           <p:nvPr/>
         </p:nvSpPr>
         <p:spPr>
           <a:xfrm>
-            <a:off x="713232" y="1837944"/>
-            <a:ext cx="329184" cy="329184"/>
-          </a:xfrm>
-          <a:prstGeom prst="ellipse">
+            <a:off x="713232" y="2395728"/>
+            <a:ext cx="33020" cy="658368"/>
+          </a:xfrm>
+          <a:prstGeom prst="rect">
             <a:avLst/>
           </a:prstGeom>
           <a:solidFill>
-            <a:srgbClr val="1F3A5F"/>
+            <a:srgbClr val="7D3B36"/>
           </a:solidFill>
           <a:ln>
             <a:noFill/>
@@ -9116,32 +10056,23 @@
           </a:fontRef>
         </p:style>
         <p:txBody>
-          <a:bodyPr rtlCol="0" anchor="ctr" lIns="0" rIns="0" tIns="0" bIns="0"/>
+          <a:bodyPr rtlCol="0" anchor="ctr"/>
           <a:lstStyle/>
           <a:p>
             <a:pPr algn="ctr"/>
-            <a:r>
-              <a:rPr sz="1200" b="1">
-                <a:solidFill>
-                  <a:srgbClr val="FFFFFF"/>
-                </a:solidFill>
-                <a:latin typeface="Calibri"/>
-              </a:rPr>
-              <a:t>1</a:t>
-            </a:r>
-          </a:p>
-        </p:txBody>
-      </p:sp>
-      <p:sp>
-        <p:nvSpPr>
-          <p:cNvPr id="7" name="TextBox 6"/>
-          <p:cNvSpPr txBox="1"/>
-          <p:nvPr/>
-        </p:nvSpPr>
-        <p:spPr>
-          <a:xfrm>
-            <a:off x="1207008" y="1783080"/>
-            <a:ext cx="8412480" cy="731520"/>
+          </a:p>
+        </p:txBody>
+      </p:sp>
+      <p:sp>
+        <p:nvSpPr>
+          <p:cNvPr id="8" name="TextBox 7"/>
+          <p:cNvSpPr txBox="1"/>
+          <p:nvPr/>
+        </p:nvSpPr>
+        <p:spPr>
+          <a:xfrm>
+            <a:off x="914400" y="2395728"/>
+            <a:ext cx="10564063" cy="658368"/>
           </a:xfrm>
           <a:prstGeom prst="rect">
             <a:avLst/>
@@ -9166,19 +10097,19 @@
               </a:spcAft>
             </a:pPr>
             <a:r>
-              <a:rPr sz="1350" b="1" i="0">
+              <a:rPr sz="1250" b="1" i="0">
                 <a:solidFill>
                   <a:srgbClr val="1A1A1A"/>
                 </a:solidFill>
                 <a:latin typeface="Calibri"/>
               </a:rPr>
-              <a:t>Confirm all 47 sources</a:t>
+              <a:t>The source links are not yet confirmed first-hand</a:t>
             </a:r>
           </a:p>
           <a:p>
             <a:pPr>
               <a:lnSpc>
-                <a:spcPct val="135000"/>
+                <a:spcPct val="133000"/>
               </a:lnSpc>
               <a:spcBef>
                 <a:spcPts val="0"/>
@@ -9188,33 +10119,33 @@
               </a:spcAft>
             </a:pPr>
             <a:r>
-              <a:rPr sz="1150" b="0" i="0">
+              <a:rPr sz="1100" b="0" i="0">
                 <a:solidFill>
                   <a:srgbClr val="4A4845"/>
                 </a:solidFill>
                 <a:latin typeface="Calibri"/>
               </a:rPr>
-              <a:t>Open every link, confirm it supports the record, log who checked it and when. Nothing else matters until this is done.</a:t>
-            </a:r>
-          </a:p>
-        </p:txBody>
-      </p:sp>
-      <p:sp>
-        <p:nvSpPr>
-          <p:cNvPr id="8" name="Rectangle 7"/>
+              <a:t>I identified them through search. The build environment blocked opening pages directly, so each link still needs to be read and confirmed. The app ships a Verify checklist for exactly this, and nothing should be presented as fact until that is done.</a:t>
+            </a:r>
+          </a:p>
+        </p:txBody>
+      </p:sp>
+      <p:sp>
+        <p:nvSpPr>
+          <p:cNvPr id="9" name="Rectangle 8"/>
           <p:cNvSpPr/>
           <p:nvPr/>
         </p:nvSpPr>
         <p:spPr>
           <a:xfrm>
-            <a:off x="10289743" y="1828800"/>
-            <a:ext cx="1188720" cy="237744"/>
+            <a:off x="713232" y="3182112"/>
+            <a:ext cx="33020" cy="658368"/>
           </a:xfrm>
           <a:prstGeom prst="rect">
             <a:avLst/>
           </a:prstGeom>
           <a:solidFill>
-            <a:srgbClr val="F4F2EE"/>
+            <a:srgbClr val="7D3B36"/>
           </a:solidFill>
           <a:ln>
             <a:noFill/>
@@ -9236,38 +10167,96 @@
           </a:fontRef>
         </p:style>
         <p:txBody>
-          <a:bodyPr rtlCol="0" anchor="ctr" lIns="64008" rIns="64008" tIns="0" bIns="0"/>
+          <a:bodyPr rtlCol="0" anchor="ctr"/>
           <a:lstStyle/>
           <a:p>
             <a:pPr algn="ctr"/>
-            <a:r>
-              <a:rPr sz="950" b="1">
-                <a:solidFill>
-                  <a:srgbClr val="7A7772"/>
-                </a:solidFill>
-                <a:latin typeface="Calibri"/>
-              </a:rPr>
-              <a:t>Half a day</a:t>
-            </a:r>
-          </a:p>
-        </p:txBody>
-      </p:sp>
-      <p:sp>
-        <p:nvSpPr>
-          <p:cNvPr id="9" name="Oval 8"/>
+          </a:p>
+        </p:txBody>
+      </p:sp>
+      <p:sp>
+        <p:nvSpPr>
+          <p:cNvPr id="10" name="TextBox 9"/>
+          <p:cNvSpPr txBox="1"/>
+          <p:nvPr/>
+        </p:nvSpPr>
+        <p:spPr>
+          <a:xfrm>
+            <a:off x="914400" y="3182112"/>
+            <a:ext cx="10564063" cy="658368"/>
+          </a:xfrm>
+          <a:prstGeom prst="rect">
+            <a:avLst/>
+          </a:prstGeom>
+          <a:noFill/>
+        </p:spPr>
+        <p:txBody>
+          <a:bodyPr wrap="square" lIns="0" rIns="0" tIns="0" bIns="0" anchor="t">
+            <a:spAutoFit/>
+          </a:bodyPr>
+          <a:lstStyle/>
+          <a:p>
+            <a:pPr algn="l">
+              <a:lnSpc>
+                <a:spcPct val="135000"/>
+              </a:lnSpc>
+              <a:spcBef>
+                <a:spcPts val="0"/>
+              </a:spcBef>
+              <a:spcAft>
+                <a:spcPts val="300"/>
+              </a:spcAft>
+            </a:pPr>
+            <a:r>
+              <a:rPr sz="1250" b="1" i="0">
+                <a:solidFill>
+                  <a:srgbClr val="1A1A1A"/>
+                </a:solidFill>
+                <a:latin typeface="Calibri"/>
+              </a:rPr>
+              <a:t>No user research exists</a:t>
+            </a:r>
+          </a:p>
+          <a:p>
+            <a:pPr>
+              <a:lnSpc>
+                <a:spcPct val="133000"/>
+              </a:lnSpc>
+              <a:spcBef>
+                <a:spcPts val="0"/>
+              </a:spcBef>
+              <a:spcAft>
+                <a:spcPts val="600"/>
+              </a:spcAft>
+            </a:pPr>
+            <a:r>
+              <a:rPr sz="1100" b="0" i="0">
+                <a:solidFill>
+                  <a:srgbClr val="4A4845"/>
+                </a:solidFill>
+                <a:latin typeface="Calibri"/>
+              </a:rPr>
+              <a:t>I have not interviewed a single recruitment or staffing professional. Every statement about what they need is my reasoning, not a finding. The alternatives slide marks which claims I tested myself and which I assumed.</a:t>
+            </a:r>
+          </a:p>
+        </p:txBody>
+      </p:sp>
+      <p:sp>
+        <p:nvSpPr>
+          <p:cNvPr id="11" name="Rectangle 10"/>
           <p:cNvSpPr/>
           <p:nvPr/>
         </p:nvSpPr>
         <p:spPr>
           <a:xfrm>
-            <a:off x="713232" y="2697480"/>
-            <a:ext cx="329184" cy="329184"/>
-          </a:xfrm>
-          <a:prstGeom prst="ellipse">
+            <a:off x="713232" y="3968496"/>
+            <a:ext cx="33020" cy="658368"/>
+          </a:xfrm>
+          <a:prstGeom prst="rect">
             <a:avLst/>
           </a:prstGeom>
           <a:solidFill>
-            <a:srgbClr val="1F3A5F"/>
+            <a:srgbClr val="7A5618"/>
           </a:solidFill>
           <a:ln>
             <a:noFill/>
@@ -9289,32 +10278,23 @@
           </a:fontRef>
         </p:style>
         <p:txBody>
-          <a:bodyPr rtlCol="0" anchor="ctr" lIns="0" rIns="0" tIns="0" bIns="0"/>
+          <a:bodyPr rtlCol="0" anchor="ctr"/>
           <a:lstStyle/>
           <a:p>
             <a:pPr algn="ctr"/>
-            <a:r>
-              <a:rPr sz="1200" b="1">
-                <a:solidFill>
-                  <a:srgbClr val="FFFFFF"/>
-                </a:solidFill>
-                <a:latin typeface="Calibri"/>
-              </a:rPr>
-              <a:t>2</a:t>
-            </a:r>
-          </a:p>
-        </p:txBody>
-      </p:sp>
-      <p:sp>
-        <p:nvSpPr>
-          <p:cNvPr id="10" name="TextBox 9"/>
-          <p:cNvSpPr txBox="1"/>
-          <p:nvPr/>
-        </p:nvSpPr>
-        <p:spPr>
-          <a:xfrm>
-            <a:off x="1207008" y="2642616"/>
-            <a:ext cx="8412480" cy="731520"/>
+          </a:p>
+        </p:txBody>
+      </p:sp>
+      <p:sp>
+        <p:nvSpPr>
+          <p:cNvPr id="12" name="TextBox 11"/>
+          <p:cNvSpPr txBox="1"/>
+          <p:nvPr/>
+        </p:nvSpPr>
+        <p:spPr>
+          <a:xfrm>
+            <a:off x="914400" y="3968496"/>
+            <a:ext cx="10564063" cy="658368"/>
           </a:xfrm>
           <a:prstGeom prst="rect">
             <a:avLst/>
@@ -9339,19 +10319,19 @@
               </a:spcAft>
             </a:pPr>
             <a:r>
-              <a:rPr sz="1350" b="1" i="0">
+              <a:rPr sz="1250" b="1" i="0">
                 <a:solidFill>
                   <a:srgbClr val="1A1A1A"/>
                 </a:solidFill>
                 <a:latin typeface="Calibri"/>
               </a:rPr>
-              <a:t>Talk to eight people who do this job</a:t>
+              <a:t>20 records is a sample, not a market</a:t>
             </a:r>
           </a:p>
           <a:p>
             <a:pPr>
               <a:lnSpc>
-                <a:spcPct val="135000"/>
+                <a:spcPct val="133000"/>
               </a:lnSpc>
               <a:spcBef>
                 <a:spcPts val="0"/>
@@ -9361,33 +10341,33 @@
               </a:spcAft>
             </a:pPr>
             <a:r>
-              <a:rPr sz="1150" b="0" i="0">
+              <a:rPr sz="1100" b="0" i="0">
                 <a:solidFill>
                   <a:srgbClr val="4A4845"/>
                 </a:solidFill>
                 <a:latin typeface="Calibri"/>
               </a:rPr>
-              <a:t>Recruitment and staffing BD leads. One question above all: what do you use today, and what would make you stop using it? This is the assumption the whole product rests on.</a:t>
-            </a:r>
-          </a:p>
-        </p:txBody>
-      </p:sp>
-      <p:sp>
-        <p:nvSpPr>
-          <p:cNvPr id="11" name="Rectangle 10"/>
+              <a:t>Coverage is skewed toward cities and states with active press communications. A count here measures reporting volume, not real activity.</a:t>
+            </a:r>
+          </a:p>
+        </p:txBody>
+      </p:sp>
+      <p:sp>
+        <p:nvSpPr>
+          <p:cNvPr id="13" name="Rectangle 12"/>
           <p:cNvSpPr/>
           <p:nvPr/>
         </p:nvSpPr>
         <p:spPr>
           <a:xfrm>
-            <a:off x="10289743" y="2688336"/>
-            <a:ext cx="1188720" cy="237744"/>
+            <a:off x="713232" y="4754880"/>
+            <a:ext cx="33020" cy="658368"/>
           </a:xfrm>
           <a:prstGeom prst="rect">
             <a:avLst/>
           </a:prstGeom>
           <a:solidFill>
-            <a:srgbClr val="F4F2EE"/>
+            <a:srgbClr val="7A5618"/>
           </a:solidFill>
           <a:ln>
             <a:noFill/>
@@ -9409,38 +10389,96 @@
           </a:fontRef>
         </p:style>
         <p:txBody>
-          <a:bodyPr rtlCol="0" anchor="ctr" lIns="64008" rIns="64008" tIns="0" bIns="0"/>
+          <a:bodyPr rtlCol="0" anchor="ctr"/>
           <a:lstStyle/>
           <a:p>
             <a:pPr algn="ctr"/>
-            <a:r>
-              <a:rPr sz="950" b="1">
-                <a:solidFill>
-                  <a:srgbClr val="7A7772"/>
-                </a:solidFill>
-                <a:latin typeface="Calibri"/>
-              </a:rPr>
-              <a:t>One week</a:t>
-            </a:r>
-          </a:p>
-        </p:txBody>
-      </p:sp>
-      <p:sp>
-        <p:nvSpPr>
-          <p:cNvPr id="12" name="Oval 11"/>
+          </a:p>
+        </p:txBody>
+      </p:sp>
+      <p:sp>
+        <p:nvSpPr>
+          <p:cNvPr id="14" name="TextBox 13"/>
+          <p:cNvSpPr txBox="1"/>
+          <p:nvPr/>
+        </p:nvSpPr>
+        <p:spPr>
+          <a:xfrm>
+            <a:off x="914400" y="4754880"/>
+            <a:ext cx="10564063" cy="658368"/>
+          </a:xfrm>
+          <a:prstGeom prst="rect">
+            <a:avLst/>
+          </a:prstGeom>
+          <a:noFill/>
+        </p:spPr>
+        <p:txBody>
+          <a:bodyPr wrap="square" lIns="0" rIns="0" tIns="0" bIns="0" anchor="t">
+            <a:spAutoFit/>
+          </a:bodyPr>
+          <a:lstStyle/>
+          <a:p>
+            <a:pPr algn="l">
+              <a:lnSpc>
+                <a:spcPct val="135000"/>
+              </a:lnSpc>
+              <a:spcBef>
+                <a:spcPts val="0"/>
+              </a:spcBef>
+              <a:spcAft>
+                <a:spcPts val="300"/>
+              </a:spcAft>
+            </a:pPr>
+            <a:r>
+              <a:rPr sz="1250" b="1" i="0">
+                <a:solidFill>
+                  <a:srgbClr val="1A1A1A"/>
+                </a:solidFill>
+                <a:latin typeface="Calibri"/>
+              </a:rPr>
+              <a:t>It cannot predict, and does not try</a:t>
+            </a:r>
+          </a:p>
+          <a:p>
+            <a:pPr>
+              <a:lnSpc>
+                <a:spcPct val="133000"/>
+              </a:lnSpc>
+              <a:spcBef>
+                <a:spcPts val="0"/>
+              </a:spcBef>
+              <a:spcAft>
+                <a:spcPts val="600"/>
+              </a:spcAft>
+            </a:pPr>
+            <a:r>
+              <a:rPr sz="1100" b="0" i="0">
+                <a:solidFill>
+                  <a:srgbClr val="4A4845"/>
+                </a:solidFill>
+                <a:latin typeface="Calibri"/>
+              </a:rPr>
+              <a:t>I looked for evidence that public signals give reliable early warning of GCC setups. I did not find enough to support that claim, so the product does not make it.</a:t>
+            </a:r>
+          </a:p>
+        </p:txBody>
+      </p:sp>
+      <p:sp>
+        <p:nvSpPr>
+          <p:cNvPr id="15" name="Rectangle 14"/>
           <p:cNvSpPr/>
           <p:nvPr/>
         </p:nvSpPr>
         <p:spPr>
           <a:xfrm>
-            <a:off x="713232" y="3557016"/>
-            <a:ext cx="329184" cy="329184"/>
-          </a:xfrm>
-          <a:prstGeom prst="ellipse">
+            <a:off x="713232" y="5541264"/>
+            <a:ext cx="33020" cy="658368"/>
+          </a:xfrm>
+          <a:prstGeom prst="rect">
             <a:avLst/>
           </a:prstGeom>
           <a:solidFill>
-            <a:srgbClr val="1F3A5F"/>
+            <a:srgbClr val="7A5618"/>
           </a:solidFill>
           <a:ln>
             <a:noFill/>
@@ -9462,32 +10500,23 @@
           </a:fontRef>
         </p:style>
         <p:txBody>
-          <a:bodyPr rtlCol="0" anchor="ctr" lIns="0" rIns="0" tIns="0" bIns="0"/>
+          <a:bodyPr rtlCol="0" anchor="ctr"/>
           <a:lstStyle/>
           <a:p>
             <a:pPr algn="ctr"/>
-            <a:r>
-              <a:rPr sz="1200" b="1">
-                <a:solidFill>
-                  <a:srgbClr val="FFFFFF"/>
-                </a:solidFill>
-                <a:latin typeface="Calibri"/>
-              </a:rPr>
-              <a:t>3</a:t>
-            </a:r>
-          </a:p>
-        </p:txBody>
-      </p:sp>
-      <p:sp>
-        <p:nvSpPr>
-          <p:cNvPr id="13" name="TextBox 12"/>
-          <p:cNvSpPr txBox="1"/>
-          <p:nvPr/>
-        </p:nvSpPr>
-        <p:spPr>
-          <a:xfrm>
-            <a:off x="1207008" y="3502152"/>
-            <a:ext cx="8412480" cy="731520"/>
+          </a:p>
+        </p:txBody>
+      </p:sp>
+      <p:sp>
+        <p:nvSpPr>
+          <p:cNvPr id="16" name="TextBox 15"/>
+          <p:cNvSpPr txBox="1"/>
+          <p:nvPr/>
+        </p:nvSpPr>
+        <p:spPr>
+          <a:xfrm>
+            <a:off x="914400" y="5541264"/>
+            <a:ext cx="10564063" cy="658368"/>
           </a:xfrm>
           <a:prstGeom prst="rect">
             <a:avLst/>
@@ -9512,19 +10541,19 @@
               </a:spcAft>
             </a:pPr>
             <a:r>
-              <a:rPr sz="1350" b="1" i="0">
+              <a:rPr sz="1250" b="1" i="0">
                 <a:solidFill>
                   <a:srgbClr val="1A1A1A"/>
                 </a:solidFill>
                 <a:latin typeface="Calibri"/>
               </a:rPr>
-              <a:t>Test whether state MoUs are an early signal</a:t>
+              <a:t>"Ask" is keyword search, not AI</a:t>
             </a:r>
           </a:p>
           <a:p>
             <a:pPr>
               <a:lnSpc>
-                <a:spcPct val="135000"/>
+                <a:spcPct val="133000"/>
               </a:lnSpc>
               <a:spcBef>
                 <a:spcPts val="0"/>
@@ -9534,419 +10563,20 @@
               </a:spcAft>
             </a:pPr>
             <a:r>
-              <a:rPr sz="1150" b="0" i="0">
+              <a:rPr sz="1100" b="0" i="0">
                 <a:solidFill>
                   <a:srgbClr val="4A4845"/>
                 </a:solidFill>
                 <a:latin typeface="Calibri"/>
               </a:rPr>
-              <a:t>One record here shows roughly 17 months between a state MoU and an opening. If that holds across 20 more cases, it is a genuinely earlier signal than anything in the dataset today.</a:t>
-            </a:r>
-          </a:p>
-        </p:txBody>
-      </p:sp>
-      <p:sp>
-        <p:nvSpPr>
-          <p:cNvPr id="14" name="Rectangle 13"/>
-          <p:cNvSpPr/>
-          <p:nvPr/>
-        </p:nvSpPr>
-        <p:spPr>
-          <a:xfrm>
-            <a:off x="10289743" y="3547872"/>
-            <a:ext cx="1188720" cy="237744"/>
-          </a:xfrm>
-          <a:prstGeom prst="rect">
-            <a:avLst/>
-          </a:prstGeom>
-          <a:solidFill>
-            <a:srgbClr val="F4F2EE"/>
-          </a:solidFill>
-          <a:ln>
-            <a:noFill/>
-          </a:ln>
-          <a:effectLst/>
-        </p:spPr>
-        <p:style>
-          <a:lnRef idx="1">
-            <a:schemeClr val="accent1"/>
-          </a:lnRef>
-          <a:fillRef idx="3">
-            <a:schemeClr val="accent1"/>
-          </a:fillRef>
-          <a:effectRef idx="2">
-            <a:schemeClr val="accent1"/>
-          </a:effectRef>
-          <a:fontRef idx="minor">
-            <a:schemeClr val="lt1"/>
-          </a:fontRef>
-        </p:style>
-        <p:txBody>
-          <a:bodyPr rtlCol="0" anchor="ctr" lIns="64008" rIns="64008" tIns="0" bIns="0"/>
-          <a:lstStyle/>
-          <a:p>
-            <a:pPr algn="ctr"/>
-            <a:r>
-              <a:rPr sz="950" b="1">
-                <a:solidFill>
-                  <a:srgbClr val="7A7772"/>
-                </a:solidFill>
-                <a:latin typeface="Calibri"/>
-              </a:rPr>
-              <a:t>One week</a:t>
-            </a:r>
-          </a:p>
-        </p:txBody>
-      </p:sp>
-      <p:sp>
-        <p:nvSpPr>
-          <p:cNvPr id="15" name="Oval 14"/>
-          <p:cNvSpPr/>
-          <p:nvPr/>
-        </p:nvSpPr>
-        <p:spPr>
-          <a:xfrm>
-            <a:off x="713232" y="4416552"/>
-            <a:ext cx="329184" cy="329184"/>
-          </a:xfrm>
-          <a:prstGeom prst="ellipse">
-            <a:avLst/>
-          </a:prstGeom>
-          <a:solidFill>
-            <a:srgbClr val="1F3A5F"/>
-          </a:solidFill>
-          <a:ln>
-            <a:noFill/>
-          </a:ln>
-          <a:effectLst/>
-        </p:spPr>
-        <p:style>
-          <a:lnRef idx="1">
-            <a:schemeClr val="accent1"/>
-          </a:lnRef>
-          <a:fillRef idx="3">
-            <a:schemeClr val="accent1"/>
-          </a:fillRef>
-          <a:effectRef idx="2">
-            <a:schemeClr val="accent1"/>
-          </a:effectRef>
-          <a:fontRef idx="minor">
-            <a:schemeClr val="lt1"/>
-          </a:fontRef>
-        </p:style>
-        <p:txBody>
-          <a:bodyPr rtlCol="0" anchor="ctr" lIns="0" rIns="0" tIns="0" bIns="0"/>
-          <a:lstStyle/>
-          <a:p>
-            <a:pPr algn="ctr"/>
-            <a:r>
-              <a:rPr sz="1200" b="1">
-                <a:solidFill>
-                  <a:srgbClr val="FFFFFF"/>
-                </a:solidFill>
-                <a:latin typeface="Calibri"/>
-              </a:rPr>
-              <a:t>4</a:t>
-            </a:r>
-          </a:p>
-        </p:txBody>
-      </p:sp>
-      <p:sp>
-        <p:nvSpPr>
-          <p:cNvPr id="16" name="TextBox 15"/>
-          <p:cNvSpPr txBox="1"/>
-          <p:nvPr/>
-        </p:nvSpPr>
-        <p:spPr>
-          <a:xfrm>
-            <a:off x="1207008" y="4361688"/>
-            <a:ext cx="8412480" cy="731520"/>
-          </a:xfrm>
-          <a:prstGeom prst="rect">
-            <a:avLst/>
-          </a:prstGeom>
-          <a:noFill/>
-        </p:spPr>
-        <p:txBody>
-          <a:bodyPr wrap="square" lIns="0" rIns="0" tIns="0" bIns="0" anchor="t">
-            <a:spAutoFit/>
-          </a:bodyPr>
-          <a:lstStyle/>
-          <a:p>
-            <a:pPr algn="l">
-              <a:lnSpc>
-                <a:spcPct val="135000"/>
-              </a:lnSpc>
-              <a:spcBef>
-                <a:spcPts val="0"/>
-              </a:spcBef>
-              <a:spcAft>
-                <a:spcPts val="300"/>
-              </a:spcAft>
-            </a:pPr>
-            <a:r>
-              <a:rPr sz="1350" b="1" i="0">
-                <a:solidFill>
-                  <a:srgbClr val="1A1A1A"/>
-                </a:solidFill>
-                <a:latin typeface="Calibri"/>
-              </a:rPr>
-              <a:t>Widen coverage with a repeatable method</a:t>
-            </a:r>
-          </a:p>
-          <a:p>
-            <a:pPr>
-              <a:lnSpc>
-                <a:spcPct val="135000"/>
-              </a:lnSpc>
-              <a:spcBef>
-                <a:spcPts val="0"/>
-              </a:spcBef>
-              <a:spcAft>
-                <a:spcPts val="600"/>
-              </a:spcAft>
-            </a:pPr>
-            <a:r>
-              <a:rPr sz="1150" b="0" i="0">
-                <a:solidFill>
-                  <a:srgbClr val="4A4845"/>
-                </a:solidFill>
-                <a:latin typeface="Calibri"/>
-              </a:rPr>
-              <a:t>Move from manual searching to a defined collection process, and record why each candidate was included or excluded.</a:t>
-            </a:r>
-          </a:p>
-        </p:txBody>
-      </p:sp>
-      <p:sp>
-        <p:nvSpPr>
-          <p:cNvPr id="17" name="Rectangle 16"/>
-          <p:cNvSpPr/>
-          <p:nvPr/>
-        </p:nvSpPr>
-        <p:spPr>
-          <a:xfrm>
-            <a:off x="10289743" y="4407408"/>
-            <a:ext cx="1188720" cy="237744"/>
-          </a:xfrm>
-          <a:prstGeom prst="rect">
-            <a:avLst/>
-          </a:prstGeom>
-          <a:solidFill>
-            <a:srgbClr val="F4F2EE"/>
-          </a:solidFill>
-          <a:ln>
-            <a:noFill/>
-          </a:ln>
-          <a:effectLst/>
-        </p:spPr>
-        <p:style>
-          <a:lnRef idx="1">
-            <a:schemeClr val="accent1"/>
-          </a:lnRef>
-          <a:fillRef idx="3">
-            <a:schemeClr val="accent1"/>
-          </a:fillRef>
-          <a:effectRef idx="2">
-            <a:schemeClr val="accent1"/>
-          </a:effectRef>
-          <a:fontRef idx="minor">
-            <a:schemeClr val="lt1"/>
-          </a:fontRef>
-        </p:style>
-        <p:txBody>
-          <a:bodyPr rtlCol="0" anchor="ctr" lIns="64008" rIns="64008" tIns="0" bIns="0"/>
-          <a:lstStyle/>
-          <a:p>
-            <a:pPr algn="ctr"/>
-            <a:r>
-              <a:rPr sz="950" b="1">
-                <a:solidFill>
-                  <a:srgbClr val="7A7772"/>
-                </a:solidFill>
-                <a:latin typeface="Calibri"/>
-              </a:rPr>
-              <a:t>Two weeks</a:t>
-            </a:r>
-          </a:p>
-        </p:txBody>
-      </p:sp>
-      <p:sp>
-        <p:nvSpPr>
-          <p:cNvPr id="18" name="Oval 17"/>
-          <p:cNvSpPr/>
-          <p:nvPr/>
-        </p:nvSpPr>
-        <p:spPr>
-          <a:xfrm>
-            <a:off x="713232" y="5276088"/>
-            <a:ext cx="329184" cy="329184"/>
-          </a:xfrm>
-          <a:prstGeom prst="ellipse">
-            <a:avLst/>
-          </a:prstGeom>
-          <a:solidFill>
-            <a:srgbClr val="1F3A5F"/>
-          </a:solidFill>
-          <a:ln>
-            <a:noFill/>
-          </a:ln>
-          <a:effectLst/>
-        </p:spPr>
-        <p:style>
-          <a:lnRef idx="1">
-            <a:schemeClr val="accent1"/>
-          </a:lnRef>
-          <a:fillRef idx="3">
-            <a:schemeClr val="accent1"/>
-          </a:fillRef>
-          <a:effectRef idx="2">
-            <a:schemeClr val="accent1"/>
-          </a:effectRef>
-          <a:fontRef idx="minor">
-            <a:schemeClr val="lt1"/>
-          </a:fontRef>
-        </p:style>
-        <p:txBody>
-          <a:bodyPr rtlCol="0" anchor="ctr" lIns="0" rIns="0" tIns="0" bIns="0"/>
-          <a:lstStyle/>
-          <a:p>
-            <a:pPr algn="ctr"/>
-            <a:r>
-              <a:rPr sz="1200" b="1">
-                <a:solidFill>
-                  <a:srgbClr val="FFFFFF"/>
-                </a:solidFill>
-                <a:latin typeface="Calibri"/>
-              </a:rPr>
-              <a:t>5</a:t>
-            </a:r>
-          </a:p>
-        </p:txBody>
-      </p:sp>
-      <p:sp>
-        <p:nvSpPr>
-          <p:cNvPr id="19" name="TextBox 18"/>
-          <p:cNvSpPr txBox="1"/>
-          <p:nvPr/>
-        </p:nvSpPr>
-        <p:spPr>
-          <a:xfrm>
-            <a:off x="1207008" y="5221224"/>
-            <a:ext cx="8412480" cy="731520"/>
-          </a:xfrm>
-          <a:prstGeom prst="rect">
-            <a:avLst/>
-          </a:prstGeom>
-          <a:noFill/>
-        </p:spPr>
-        <p:txBody>
-          <a:bodyPr wrap="square" lIns="0" rIns="0" tIns="0" bIns="0" anchor="t">
-            <a:spAutoFit/>
-          </a:bodyPr>
-          <a:lstStyle/>
-          <a:p>
-            <a:pPr algn="l">
-              <a:lnSpc>
-                <a:spcPct val="135000"/>
-              </a:lnSpc>
-              <a:spcBef>
-                <a:spcPts val="0"/>
-              </a:spcBef>
-              <a:spcAft>
-                <a:spcPts val="300"/>
-              </a:spcAft>
-            </a:pPr>
-            <a:r>
-              <a:rPr sz="1350" b="1" i="0">
-                <a:solidFill>
-                  <a:srgbClr val="1A1A1A"/>
-                </a:solidFill>
-                <a:latin typeface="Calibri"/>
-              </a:rPr>
-              <a:t>Add company registry data</a:t>
-            </a:r>
-          </a:p>
-          <a:p>
-            <a:pPr>
-              <a:lnSpc>
-                <a:spcPct val="135000"/>
-              </a:lnSpc>
-              <a:spcBef>
-                <a:spcPts val="0"/>
-              </a:spcBef>
-              <a:spcAft>
-                <a:spcPts val="600"/>
-              </a:spcAft>
-            </a:pPr>
-            <a:r>
-              <a:rPr sz="1150" b="0" i="0">
-                <a:solidFill>
-                  <a:srgbClr val="4A4845"/>
-                </a:solidFill>
-                <a:latin typeface="Calibri"/>
-              </a:rPr>
-              <a:t>Tie each centre to its Indian legal entity, so the same company is never counted twice under two names.</a:t>
-            </a:r>
-          </a:p>
-        </p:txBody>
-      </p:sp>
-      <p:sp>
-        <p:nvSpPr>
-          <p:cNvPr id="20" name="Rectangle 19"/>
-          <p:cNvSpPr/>
-          <p:nvPr/>
-        </p:nvSpPr>
-        <p:spPr>
-          <a:xfrm>
-            <a:off x="10289743" y="5266944"/>
-            <a:ext cx="1188720" cy="237744"/>
-          </a:xfrm>
-          <a:prstGeom prst="rect">
-            <a:avLst/>
-          </a:prstGeom>
-          <a:solidFill>
-            <a:srgbClr val="F4F2EE"/>
-          </a:solidFill>
-          <a:ln>
-            <a:noFill/>
-          </a:ln>
-          <a:effectLst/>
-        </p:spPr>
-        <p:style>
-          <a:lnRef idx="1">
-            <a:schemeClr val="accent1"/>
-          </a:lnRef>
-          <a:fillRef idx="3">
-            <a:schemeClr val="accent1"/>
-          </a:fillRef>
-          <a:effectRef idx="2">
-            <a:schemeClr val="accent1"/>
-          </a:effectRef>
-          <a:fontRef idx="minor">
-            <a:schemeClr val="lt1"/>
-          </a:fontRef>
-        </p:style>
-        <p:txBody>
-          <a:bodyPr rtlCol="0" anchor="ctr" lIns="64008" rIns="64008" tIns="0" bIns="0"/>
-          <a:lstStyle/>
-          <a:p>
-            <a:pPr algn="ctr"/>
-            <a:r>
-              <a:rPr sz="950" b="1">
-                <a:solidFill>
-                  <a:srgbClr val="7A7772"/>
-                </a:solidFill>
-                <a:latin typeface="Calibri"/>
-              </a:rPr>
-              <a:t>Later</a:t>
-            </a:r>
-          </a:p>
-        </p:txBody>
-      </p:sp>
-      <p:sp>
-        <p:nvSpPr>
-          <p:cNvPr id="21" name="TextBox 20"/>
+              <a:t>It scores records by word overlap and detects a few patterns. The app says so on the page itself. No model, no API key, no cost.</a:t>
+            </a:r>
+          </a:p>
+        </p:txBody>
+      </p:sp>
+      <p:sp>
+        <p:nvSpPr>
+          <p:cNvPr id="17" name="TextBox 16"/>
           <p:cNvSpPr txBox="1"/>
           <p:nvPr/>
         </p:nvSpPr>
@@ -9990,14 +10620,14 @@
                 </a:solidFill>
                 <a:latin typeface="Calibri"/>
               </a:rPr>
-              <a:t>   ·   Next steps</a:t>
-            </a:r>
-          </a:p>
-        </p:txBody>
-      </p:sp>
-      <p:sp>
-        <p:nvSpPr>
-          <p:cNvPr id="22" name="TextBox 21"/>
+              <a:t>   ·   Limitations &amp; assumptions</a:t>
+            </a:r>
+          </a:p>
+        </p:txBody>
+      </p:sp>
+      <p:sp>
+        <p:nvSpPr>
+          <p:cNvPr id="18" name="TextBox 17"/>
           <p:cNvSpPr txBox="1"/>
           <p:nvPr/>
         </p:nvSpPr>
@@ -10073,7 +10703,7 @@
             <a:avLst/>
           </a:prstGeom>
           <a:solidFill>
-            <a:srgbClr val="FFFFFF"/>
+            <a:srgbClr val="FBFAF8"/>
           </a:solidFill>
           <a:ln>
             <a:noFill/>
@@ -10104,16 +10734,150 @@
       </p:sp>
       <p:sp>
         <p:nvSpPr>
-          <p:cNvPr id="3" name="Rectangle 2"/>
+          <p:cNvPr id="3" name="TextBox 2"/>
+          <p:cNvSpPr txBox="1"/>
+          <p:nvPr/>
+        </p:nvSpPr>
+        <p:spPr>
+          <a:xfrm>
+            <a:off x="713232" y="475488"/>
+            <a:ext cx="10765231" cy="237744"/>
+          </a:xfrm>
+          <a:prstGeom prst="rect">
+            <a:avLst/>
+          </a:prstGeom>
+          <a:noFill/>
+        </p:spPr>
+        <p:txBody>
+          <a:bodyPr wrap="square" lIns="0" rIns="0" tIns="0" bIns="0" anchor="t">
+            <a:spAutoFit/>
+          </a:bodyPr>
+          <a:lstStyle/>
+          <a:p>
+            <a:pPr algn="l">
+              <a:lnSpc>
+                <a:spcPct val="135000"/>
+              </a:lnSpc>
+              <a:spcBef>
+                <a:spcPts val="0"/>
+              </a:spcBef>
+              <a:spcAft>
+                <a:spcPts val="0"/>
+              </a:spcAft>
+            </a:pPr>
+            <a:r>
+              <a:rPr sz="1050" b="1" i="0">
+                <a:solidFill>
+                  <a:srgbClr val="7A7772"/>
+                </a:solidFill>
+                <a:latin typeface="Calibri"/>
+              </a:rPr>
+              <a:t>NEXT</a:t>
+            </a:r>
+          </a:p>
+        </p:txBody>
+      </p:sp>
+      <p:sp>
+        <p:nvSpPr>
+          <p:cNvPr id="4" name="TextBox 3"/>
+          <p:cNvSpPr txBox="1"/>
+          <p:nvPr/>
+        </p:nvSpPr>
+        <p:spPr>
+          <a:xfrm>
+            <a:off x="713232" y="768096"/>
+            <a:ext cx="10765231" cy="914400"/>
+          </a:xfrm>
+          <a:prstGeom prst="rect">
+            <a:avLst/>
+          </a:prstGeom>
+          <a:noFill/>
+        </p:spPr>
+        <p:txBody>
+          <a:bodyPr wrap="square" lIns="0" rIns="0" tIns="0" bIns="0" anchor="t">
+            <a:spAutoFit/>
+          </a:bodyPr>
+          <a:lstStyle/>
+          <a:p>
+            <a:pPr algn="l">
+              <a:lnSpc>
+                <a:spcPct val="112000"/>
+              </a:lnSpc>
+              <a:spcBef>
+                <a:spcPts val="0"/>
+              </a:spcBef>
+              <a:spcAft>
+                <a:spcPts val="0"/>
+              </a:spcAft>
+            </a:pPr>
+            <a:r>
+              <a:rPr sz="3200" b="0" i="0">
+                <a:solidFill>
+                  <a:srgbClr val="1A1A1A"/>
+                </a:solidFill>
+                <a:latin typeface="Georgia"/>
+              </a:rPr>
+              <a:t>What I would do next, in order</a:t>
+            </a:r>
+          </a:p>
+        </p:txBody>
+      </p:sp>
+      <p:sp>
+        <p:nvSpPr>
+          <p:cNvPr id="5" name="Rectangle 4"/>
           <p:cNvSpPr/>
           <p:nvPr/>
         </p:nvSpPr>
         <p:spPr>
           <a:xfrm>
-            <a:off x="0" y="0"/>
-            <a:ext cx="118872" cy="6858000"/>
-          </a:xfrm>
-          <a:prstGeom prst="rect">
+            <a:off x="713232" y="1426464"/>
+            <a:ext cx="10765231" cy="11430"/>
+          </a:xfrm>
+          <a:prstGeom prst="rect">
+            <a:avLst/>
+          </a:prstGeom>
+          <a:solidFill>
+            <a:srgbClr val="E2DED7"/>
+          </a:solidFill>
+          <a:ln>
+            <a:noFill/>
+          </a:ln>
+          <a:effectLst/>
+        </p:spPr>
+        <p:style>
+          <a:lnRef idx="1">
+            <a:schemeClr val="accent1"/>
+          </a:lnRef>
+          <a:fillRef idx="3">
+            <a:schemeClr val="accent1"/>
+          </a:fillRef>
+          <a:effectRef idx="2">
+            <a:schemeClr val="accent1"/>
+          </a:effectRef>
+          <a:fontRef idx="minor">
+            <a:schemeClr val="lt1"/>
+          </a:fontRef>
+        </p:style>
+        <p:txBody>
+          <a:bodyPr rtlCol="0" anchor="ctr"/>
+          <a:lstStyle/>
+          <a:p>
+            <a:pPr algn="ctr"/>
+          </a:p>
+        </p:txBody>
+      </p:sp>
+      <p:sp>
+        <p:nvSpPr>
+          <p:cNvPr id="6" name="Oval 5"/>
+          <p:cNvSpPr/>
+          <p:nvPr/>
+        </p:nvSpPr>
+        <p:spPr>
+          <a:xfrm>
+            <a:off x="713232" y="1837944"/>
+            <a:ext cx="329184" cy="329184"/>
+          </a:xfrm>
+          <a:prstGeom prst="ellipse">
             <a:avLst/>
           </a:prstGeom>
           <a:solidFill>
@@ -10139,23 +10903,32 @@
           </a:fontRef>
         </p:style>
         <p:txBody>
-          <a:bodyPr rtlCol="0" anchor="ctr"/>
+          <a:bodyPr rtlCol="0" anchor="ctr" lIns="0" rIns="0" tIns="0" bIns="0"/>
           <a:lstStyle/>
           <a:p>
             <a:pPr algn="ctr"/>
-          </a:p>
-        </p:txBody>
-      </p:sp>
-      <p:sp>
-        <p:nvSpPr>
-          <p:cNvPr id="4" name="TextBox 3"/>
-          <p:cNvSpPr txBox="1"/>
-          <p:nvPr/>
-        </p:nvSpPr>
-        <p:spPr>
-          <a:xfrm>
-            <a:off x="1143000" y="1691640"/>
-            <a:ext cx="9509760" cy="914400"/>
+            <a:r>
+              <a:rPr sz="1200" b="1">
+                <a:solidFill>
+                  <a:srgbClr val="FFFFFF"/>
+                </a:solidFill>
+                <a:latin typeface="Calibri"/>
+              </a:rPr>
+              <a:t>1</a:t>
+            </a:r>
+          </a:p>
+        </p:txBody>
+      </p:sp>
+      <p:sp>
+        <p:nvSpPr>
+          <p:cNvPr id="7" name="TextBox 6"/>
+          <p:cNvSpPr txBox="1"/>
+          <p:nvPr/>
+        </p:nvSpPr>
+        <p:spPr>
+          <a:xfrm>
+            <a:off x="1207008" y="1783080"/>
+            <a:ext cx="8412480" cy="731520"/>
           </a:xfrm>
           <a:prstGeom prst="rect">
             <a:avLst/>
@@ -10176,56 +10949,108 @@
                 <a:spcPts val="0"/>
               </a:spcBef>
               <a:spcAft>
-                <a:spcPts val="1600"/>
-              </a:spcAft>
-            </a:pPr>
-            <a:r>
-              <a:rPr sz="1500" b="1" i="0">
+                <a:spcPts val="300"/>
+              </a:spcAft>
+            </a:pPr>
+            <a:r>
+              <a:rPr sz="1350" b="1" i="0">
+                <a:solidFill>
+                  <a:srgbClr val="1A1A1A"/>
+                </a:solidFill>
+                <a:latin typeface="Calibri"/>
+              </a:rPr>
+              <a:t>Confirm all 47 sources</a:t>
+            </a:r>
+          </a:p>
+          <a:p>
+            <a:pPr>
+              <a:lnSpc>
+                <a:spcPct val="135000"/>
+              </a:lnSpc>
+              <a:spcBef>
+                <a:spcPts val="0"/>
+              </a:spcBef>
+              <a:spcAft>
+                <a:spcPts val="600"/>
+              </a:spcAft>
+            </a:pPr>
+            <a:r>
+              <a:rPr sz="1150" b="0" i="0">
+                <a:solidFill>
+                  <a:srgbClr val="4A4845"/>
+                </a:solidFill>
+                <a:latin typeface="Calibri"/>
+              </a:rPr>
+              <a:t>Open every link, confirm it supports the record, log who checked it and when. Nothing else matters until this is done.</a:t>
+            </a:r>
+          </a:p>
+        </p:txBody>
+      </p:sp>
+      <p:sp>
+        <p:nvSpPr>
+          <p:cNvPr id="8" name="Rectangle 7"/>
+          <p:cNvSpPr/>
+          <p:nvPr/>
+        </p:nvSpPr>
+        <p:spPr>
+          <a:xfrm>
+            <a:off x="10289743" y="1828800"/>
+            <a:ext cx="1188720" cy="237744"/>
+          </a:xfrm>
+          <a:prstGeom prst="rect">
+            <a:avLst/>
+          </a:prstGeom>
+          <a:solidFill>
+            <a:srgbClr val="F4F2EE"/>
+          </a:solidFill>
+          <a:ln>
+            <a:noFill/>
+          </a:ln>
+          <a:effectLst/>
+        </p:spPr>
+        <p:style>
+          <a:lnRef idx="1">
+            <a:schemeClr val="accent1"/>
+          </a:lnRef>
+          <a:fillRef idx="3">
+            <a:schemeClr val="accent1"/>
+          </a:fillRef>
+          <a:effectRef idx="2">
+            <a:schemeClr val="accent1"/>
+          </a:effectRef>
+          <a:fontRef idx="minor">
+            <a:schemeClr val="lt1"/>
+          </a:fontRef>
+        </p:style>
+        <p:txBody>
+          <a:bodyPr rtlCol="0" anchor="ctr" lIns="64008" rIns="64008" tIns="0" bIns="0"/>
+          <a:lstStyle/>
+          <a:p>
+            <a:pPr algn="ctr"/>
+            <a:r>
+              <a:rPr sz="950" b="1">
                 <a:solidFill>
                   <a:srgbClr val="7A7772"/>
                 </a:solidFill>
                 <a:latin typeface="Calibri"/>
               </a:rPr>
-              <a:t>The argument in one line</a:t>
-            </a:r>
-          </a:p>
-          <a:p>
-            <a:pPr>
-              <a:lnSpc>
-                <a:spcPct val="125000"/>
-              </a:lnSpc>
-              <a:spcBef>
-                <a:spcPts val="0"/>
-              </a:spcBef>
-              <a:spcAft>
-                <a:spcPts val="2000"/>
-              </a:spcAft>
-            </a:pPr>
-            <a:r>
-              <a:rPr sz="3000" b="0" i="0">
-                <a:solidFill>
-                  <a:srgbClr val="1A1A1A"/>
-                </a:solidFill>
-                <a:latin typeface="Georgia"/>
-              </a:rPr>
-              <a:t>This market does not lack information.
-It lacks information you can check.</a:t>
-            </a:r>
-          </a:p>
-        </p:txBody>
-      </p:sp>
-      <p:sp>
-        <p:nvSpPr>
-          <p:cNvPr id="5" name="Rectangle 4"/>
+              <a:t>Half a day</a:t>
+            </a:r>
+          </a:p>
+        </p:txBody>
+      </p:sp>
+      <p:sp>
+        <p:nvSpPr>
+          <p:cNvPr id="9" name="Oval 8"/>
           <p:cNvSpPr/>
           <p:nvPr/>
         </p:nvSpPr>
         <p:spPr>
           <a:xfrm>
-            <a:off x="1143000" y="3886200"/>
-            <a:ext cx="1828800" cy="11430"/>
-          </a:xfrm>
-          <a:prstGeom prst="rect">
+            <a:off x="713232" y="2697480"/>
+            <a:ext cx="329184" cy="329184"/>
+          </a:xfrm>
+          <a:prstGeom prst="ellipse">
             <a:avLst/>
           </a:prstGeom>
           <a:solidFill>
@@ -10251,6 +11076,968 @@
           </a:fontRef>
         </p:style>
         <p:txBody>
+          <a:bodyPr rtlCol="0" anchor="ctr" lIns="0" rIns="0" tIns="0" bIns="0"/>
+          <a:lstStyle/>
+          <a:p>
+            <a:pPr algn="ctr"/>
+            <a:r>
+              <a:rPr sz="1200" b="1">
+                <a:solidFill>
+                  <a:srgbClr val="FFFFFF"/>
+                </a:solidFill>
+                <a:latin typeface="Calibri"/>
+              </a:rPr>
+              <a:t>2</a:t>
+            </a:r>
+          </a:p>
+        </p:txBody>
+      </p:sp>
+      <p:sp>
+        <p:nvSpPr>
+          <p:cNvPr id="10" name="TextBox 9"/>
+          <p:cNvSpPr txBox="1"/>
+          <p:nvPr/>
+        </p:nvSpPr>
+        <p:spPr>
+          <a:xfrm>
+            <a:off x="1207008" y="2642616"/>
+            <a:ext cx="8412480" cy="731520"/>
+          </a:xfrm>
+          <a:prstGeom prst="rect">
+            <a:avLst/>
+          </a:prstGeom>
+          <a:noFill/>
+        </p:spPr>
+        <p:txBody>
+          <a:bodyPr wrap="square" lIns="0" rIns="0" tIns="0" bIns="0" anchor="t">
+            <a:spAutoFit/>
+          </a:bodyPr>
+          <a:lstStyle/>
+          <a:p>
+            <a:pPr algn="l">
+              <a:lnSpc>
+                <a:spcPct val="135000"/>
+              </a:lnSpc>
+              <a:spcBef>
+                <a:spcPts val="0"/>
+              </a:spcBef>
+              <a:spcAft>
+                <a:spcPts val="300"/>
+              </a:spcAft>
+            </a:pPr>
+            <a:r>
+              <a:rPr sz="1350" b="1" i="0">
+                <a:solidFill>
+                  <a:srgbClr val="1A1A1A"/>
+                </a:solidFill>
+                <a:latin typeface="Calibri"/>
+              </a:rPr>
+              <a:t>Talk to eight people who do this job</a:t>
+            </a:r>
+          </a:p>
+          <a:p>
+            <a:pPr>
+              <a:lnSpc>
+                <a:spcPct val="135000"/>
+              </a:lnSpc>
+              <a:spcBef>
+                <a:spcPts val="0"/>
+              </a:spcBef>
+              <a:spcAft>
+                <a:spcPts val="600"/>
+              </a:spcAft>
+            </a:pPr>
+            <a:r>
+              <a:rPr sz="1150" b="0" i="0">
+                <a:solidFill>
+                  <a:srgbClr val="4A4845"/>
+                </a:solidFill>
+                <a:latin typeface="Calibri"/>
+              </a:rPr>
+              <a:t>Recruitment and staffing BD leads. One question above all: what do you use today, and what would make you stop using it? This is the assumption the whole product rests on.</a:t>
+            </a:r>
+          </a:p>
+        </p:txBody>
+      </p:sp>
+      <p:sp>
+        <p:nvSpPr>
+          <p:cNvPr id="11" name="Rectangle 10"/>
+          <p:cNvSpPr/>
+          <p:nvPr/>
+        </p:nvSpPr>
+        <p:spPr>
+          <a:xfrm>
+            <a:off x="10289743" y="2688336"/>
+            <a:ext cx="1188720" cy="237744"/>
+          </a:xfrm>
+          <a:prstGeom prst="rect">
+            <a:avLst/>
+          </a:prstGeom>
+          <a:solidFill>
+            <a:srgbClr val="F4F2EE"/>
+          </a:solidFill>
+          <a:ln>
+            <a:noFill/>
+          </a:ln>
+          <a:effectLst/>
+        </p:spPr>
+        <p:style>
+          <a:lnRef idx="1">
+            <a:schemeClr val="accent1"/>
+          </a:lnRef>
+          <a:fillRef idx="3">
+            <a:schemeClr val="accent1"/>
+          </a:fillRef>
+          <a:effectRef idx="2">
+            <a:schemeClr val="accent1"/>
+          </a:effectRef>
+          <a:fontRef idx="minor">
+            <a:schemeClr val="lt1"/>
+          </a:fontRef>
+        </p:style>
+        <p:txBody>
+          <a:bodyPr rtlCol="0" anchor="ctr" lIns="64008" rIns="64008" tIns="0" bIns="0"/>
+          <a:lstStyle/>
+          <a:p>
+            <a:pPr algn="ctr"/>
+            <a:r>
+              <a:rPr sz="950" b="1">
+                <a:solidFill>
+                  <a:srgbClr val="7A7772"/>
+                </a:solidFill>
+                <a:latin typeface="Calibri"/>
+              </a:rPr>
+              <a:t>One week</a:t>
+            </a:r>
+          </a:p>
+        </p:txBody>
+      </p:sp>
+      <p:sp>
+        <p:nvSpPr>
+          <p:cNvPr id="12" name="Oval 11"/>
+          <p:cNvSpPr/>
+          <p:nvPr/>
+        </p:nvSpPr>
+        <p:spPr>
+          <a:xfrm>
+            <a:off x="713232" y="3557016"/>
+            <a:ext cx="329184" cy="329184"/>
+          </a:xfrm>
+          <a:prstGeom prst="ellipse">
+            <a:avLst/>
+          </a:prstGeom>
+          <a:solidFill>
+            <a:srgbClr val="1F3A5F"/>
+          </a:solidFill>
+          <a:ln>
+            <a:noFill/>
+          </a:ln>
+          <a:effectLst/>
+        </p:spPr>
+        <p:style>
+          <a:lnRef idx="1">
+            <a:schemeClr val="accent1"/>
+          </a:lnRef>
+          <a:fillRef idx="3">
+            <a:schemeClr val="accent1"/>
+          </a:fillRef>
+          <a:effectRef idx="2">
+            <a:schemeClr val="accent1"/>
+          </a:effectRef>
+          <a:fontRef idx="minor">
+            <a:schemeClr val="lt1"/>
+          </a:fontRef>
+        </p:style>
+        <p:txBody>
+          <a:bodyPr rtlCol="0" anchor="ctr" lIns="0" rIns="0" tIns="0" bIns="0"/>
+          <a:lstStyle/>
+          <a:p>
+            <a:pPr algn="ctr"/>
+            <a:r>
+              <a:rPr sz="1200" b="1">
+                <a:solidFill>
+                  <a:srgbClr val="FFFFFF"/>
+                </a:solidFill>
+                <a:latin typeface="Calibri"/>
+              </a:rPr>
+              <a:t>3</a:t>
+            </a:r>
+          </a:p>
+        </p:txBody>
+      </p:sp>
+      <p:sp>
+        <p:nvSpPr>
+          <p:cNvPr id="13" name="TextBox 12"/>
+          <p:cNvSpPr txBox="1"/>
+          <p:nvPr/>
+        </p:nvSpPr>
+        <p:spPr>
+          <a:xfrm>
+            <a:off x="1207008" y="3502152"/>
+            <a:ext cx="8412480" cy="731520"/>
+          </a:xfrm>
+          <a:prstGeom prst="rect">
+            <a:avLst/>
+          </a:prstGeom>
+          <a:noFill/>
+        </p:spPr>
+        <p:txBody>
+          <a:bodyPr wrap="square" lIns="0" rIns="0" tIns="0" bIns="0" anchor="t">
+            <a:spAutoFit/>
+          </a:bodyPr>
+          <a:lstStyle/>
+          <a:p>
+            <a:pPr algn="l">
+              <a:lnSpc>
+                <a:spcPct val="135000"/>
+              </a:lnSpc>
+              <a:spcBef>
+                <a:spcPts val="0"/>
+              </a:spcBef>
+              <a:spcAft>
+                <a:spcPts val="300"/>
+              </a:spcAft>
+            </a:pPr>
+            <a:r>
+              <a:rPr sz="1350" b="1" i="0">
+                <a:solidFill>
+                  <a:srgbClr val="1A1A1A"/>
+                </a:solidFill>
+                <a:latin typeface="Calibri"/>
+              </a:rPr>
+              <a:t>Test whether state MoUs are an early signal</a:t>
+            </a:r>
+          </a:p>
+          <a:p>
+            <a:pPr>
+              <a:lnSpc>
+                <a:spcPct val="135000"/>
+              </a:lnSpc>
+              <a:spcBef>
+                <a:spcPts val="0"/>
+              </a:spcBef>
+              <a:spcAft>
+                <a:spcPts val="600"/>
+              </a:spcAft>
+            </a:pPr>
+            <a:r>
+              <a:rPr sz="1150" b="0" i="0">
+                <a:solidFill>
+                  <a:srgbClr val="4A4845"/>
+                </a:solidFill>
+                <a:latin typeface="Calibri"/>
+              </a:rPr>
+              <a:t>One record here shows roughly 17 months between a state MoU and an opening. If that holds across 20 more cases, it is a genuinely earlier signal than anything in the dataset today.</a:t>
+            </a:r>
+          </a:p>
+        </p:txBody>
+      </p:sp>
+      <p:sp>
+        <p:nvSpPr>
+          <p:cNvPr id="14" name="Rectangle 13"/>
+          <p:cNvSpPr/>
+          <p:nvPr/>
+        </p:nvSpPr>
+        <p:spPr>
+          <a:xfrm>
+            <a:off x="10289743" y="3547872"/>
+            <a:ext cx="1188720" cy="237744"/>
+          </a:xfrm>
+          <a:prstGeom prst="rect">
+            <a:avLst/>
+          </a:prstGeom>
+          <a:solidFill>
+            <a:srgbClr val="F4F2EE"/>
+          </a:solidFill>
+          <a:ln>
+            <a:noFill/>
+          </a:ln>
+          <a:effectLst/>
+        </p:spPr>
+        <p:style>
+          <a:lnRef idx="1">
+            <a:schemeClr val="accent1"/>
+          </a:lnRef>
+          <a:fillRef idx="3">
+            <a:schemeClr val="accent1"/>
+          </a:fillRef>
+          <a:effectRef idx="2">
+            <a:schemeClr val="accent1"/>
+          </a:effectRef>
+          <a:fontRef idx="minor">
+            <a:schemeClr val="lt1"/>
+          </a:fontRef>
+        </p:style>
+        <p:txBody>
+          <a:bodyPr rtlCol="0" anchor="ctr" lIns="64008" rIns="64008" tIns="0" bIns="0"/>
+          <a:lstStyle/>
+          <a:p>
+            <a:pPr algn="ctr"/>
+            <a:r>
+              <a:rPr sz="950" b="1">
+                <a:solidFill>
+                  <a:srgbClr val="7A7772"/>
+                </a:solidFill>
+                <a:latin typeface="Calibri"/>
+              </a:rPr>
+              <a:t>One week</a:t>
+            </a:r>
+          </a:p>
+        </p:txBody>
+      </p:sp>
+      <p:sp>
+        <p:nvSpPr>
+          <p:cNvPr id="15" name="Oval 14"/>
+          <p:cNvSpPr/>
+          <p:nvPr/>
+        </p:nvSpPr>
+        <p:spPr>
+          <a:xfrm>
+            <a:off x="713232" y="4416552"/>
+            <a:ext cx="329184" cy="329184"/>
+          </a:xfrm>
+          <a:prstGeom prst="ellipse">
+            <a:avLst/>
+          </a:prstGeom>
+          <a:solidFill>
+            <a:srgbClr val="1F3A5F"/>
+          </a:solidFill>
+          <a:ln>
+            <a:noFill/>
+          </a:ln>
+          <a:effectLst/>
+        </p:spPr>
+        <p:style>
+          <a:lnRef idx="1">
+            <a:schemeClr val="accent1"/>
+          </a:lnRef>
+          <a:fillRef idx="3">
+            <a:schemeClr val="accent1"/>
+          </a:fillRef>
+          <a:effectRef idx="2">
+            <a:schemeClr val="accent1"/>
+          </a:effectRef>
+          <a:fontRef idx="minor">
+            <a:schemeClr val="lt1"/>
+          </a:fontRef>
+        </p:style>
+        <p:txBody>
+          <a:bodyPr rtlCol="0" anchor="ctr" lIns="0" rIns="0" tIns="0" bIns="0"/>
+          <a:lstStyle/>
+          <a:p>
+            <a:pPr algn="ctr"/>
+            <a:r>
+              <a:rPr sz="1200" b="1">
+                <a:solidFill>
+                  <a:srgbClr val="FFFFFF"/>
+                </a:solidFill>
+                <a:latin typeface="Calibri"/>
+              </a:rPr>
+              <a:t>4</a:t>
+            </a:r>
+          </a:p>
+        </p:txBody>
+      </p:sp>
+      <p:sp>
+        <p:nvSpPr>
+          <p:cNvPr id="16" name="TextBox 15"/>
+          <p:cNvSpPr txBox="1"/>
+          <p:nvPr/>
+        </p:nvSpPr>
+        <p:spPr>
+          <a:xfrm>
+            <a:off x="1207008" y="4361688"/>
+            <a:ext cx="8412480" cy="731520"/>
+          </a:xfrm>
+          <a:prstGeom prst="rect">
+            <a:avLst/>
+          </a:prstGeom>
+          <a:noFill/>
+        </p:spPr>
+        <p:txBody>
+          <a:bodyPr wrap="square" lIns="0" rIns="0" tIns="0" bIns="0" anchor="t">
+            <a:spAutoFit/>
+          </a:bodyPr>
+          <a:lstStyle/>
+          <a:p>
+            <a:pPr algn="l">
+              <a:lnSpc>
+                <a:spcPct val="135000"/>
+              </a:lnSpc>
+              <a:spcBef>
+                <a:spcPts val="0"/>
+              </a:spcBef>
+              <a:spcAft>
+                <a:spcPts val="300"/>
+              </a:spcAft>
+            </a:pPr>
+            <a:r>
+              <a:rPr sz="1350" b="1" i="0">
+                <a:solidFill>
+                  <a:srgbClr val="1A1A1A"/>
+                </a:solidFill>
+                <a:latin typeface="Calibri"/>
+              </a:rPr>
+              <a:t>Widen coverage with a repeatable method</a:t>
+            </a:r>
+          </a:p>
+          <a:p>
+            <a:pPr>
+              <a:lnSpc>
+                <a:spcPct val="135000"/>
+              </a:lnSpc>
+              <a:spcBef>
+                <a:spcPts val="0"/>
+              </a:spcBef>
+              <a:spcAft>
+                <a:spcPts val="600"/>
+              </a:spcAft>
+            </a:pPr>
+            <a:r>
+              <a:rPr sz="1150" b="0" i="0">
+                <a:solidFill>
+                  <a:srgbClr val="4A4845"/>
+                </a:solidFill>
+                <a:latin typeface="Calibri"/>
+              </a:rPr>
+              <a:t>Move from manual searching to a defined collection process, and record why each candidate was included or excluded.</a:t>
+            </a:r>
+          </a:p>
+        </p:txBody>
+      </p:sp>
+      <p:sp>
+        <p:nvSpPr>
+          <p:cNvPr id="17" name="Rectangle 16"/>
+          <p:cNvSpPr/>
+          <p:nvPr/>
+        </p:nvSpPr>
+        <p:spPr>
+          <a:xfrm>
+            <a:off x="10289743" y="4407408"/>
+            <a:ext cx="1188720" cy="237744"/>
+          </a:xfrm>
+          <a:prstGeom prst="rect">
+            <a:avLst/>
+          </a:prstGeom>
+          <a:solidFill>
+            <a:srgbClr val="F4F2EE"/>
+          </a:solidFill>
+          <a:ln>
+            <a:noFill/>
+          </a:ln>
+          <a:effectLst/>
+        </p:spPr>
+        <p:style>
+          <a:lnRef idx="1">
+            <a:schemeClr val="accent1"/>
+          </a:lnRef>
+          <a:fillRef idx="3">
+            <a:schemeClr val="accent1"/>
+          </a:fillRef>
+          <a:effectRef idx="2">
+            <a:schemeClr val="accent1"/>
+          </a:effectRef>
+          <a:fontRef idx="minor">
+            <a:schemeClr val="lt1"/>
+          </a:fontRef>
+        </p:style>
+        <p:txBody>
+          <a:bodyPr rtlCol="0" anchor="ctr" lIns="64008" rIns="64008" tIns="0" bIns="0"/>
+          <a:lstStyle/>
+          <a:p>
+            <a:pPr algn="ctr"/>
+            <a:r>
+              <a:rPr sz="950" b="1">
+                <a:solidFill>
+                  <a:srgbClr val="7A7772"/>
+                </a:solidFill>
+                <a:latin typeface="Calibri"/>
+              </a:rPr>
+              <a:t>Two weeks</a:t>
+            </a:r>
+          </a:p>
+        </p:txBody>
+      </p:sp>
+      <p:sp>
+        <p:nvSpPr>
+          <p:cNvPr id="18" name="Oval 17"/>
+          <p:cNvSpPr/>
+          <p:nvPr/>
+        </p:nvSpPr>
+        <p:spPr>
+          <a:xfrm>
+            <a:off x="713232" y="5276088"/>
+            <a:ext cx="329184" cy="329184"/>
+          </a:xfrm>
+          <a:prstGeom prst="ellipse">
+            <a:avLst/>
+          </a:prstGeom>
+          <a:solidFill>
+            <a:srgbClr val="1F3A5F"/>
+          </a:solidFill>
+          <a:ln>
+            <a:noFill/>
+          </a:ln>
+          <a:effectLst/>
+        </p:spPr>
+        <p:style>
+          <a:lnRef idx="1">
+            <a:schemeClr val="accent1"/>
+          </a:lnRef>
+          <a:fillRef idx="3">
+            <a:schemeClr val="accent1"/>
+          </a:fillRef>
+          <a:effectRef idx="2">
+            <a:schemeClr val="accent1"/>
+          </a:effectRef>
+          <a:fontRef idx="minor">
+            <a:schemeClr val="lt1"/>
+          </a:fontRef>
+        </p:style>
+        <p:txBody>
+          <a:bodyPr rtlCol="0" anchor="ctr" lIns="0" rIns="0" tIns="0" bIns="0"/>
+          <a:lstStyle/>
+          <a:p>
+            <a:pPr algn="ctr"/>
+            <a:r>
+              <a:rPr sz="1200" b="1">
+                <a:solidFill>
+                  <a:srgbClr val="FFFFFF"/>
+                </a:solidFill>
+                <a:latin typeface="Calibri"/>
+              </a:rPr>
+              <a:t>5</a:t>
+            </a:r>
+          </a:p>
+        </p:txBody>
+      </p:sp>
+      <p:sp>
+        <p:nvSpPr>
+          <p:cNvPr id="19" name="TextBox 18"/>
+          <p:cNvSpPr txBox="1"/>
+          <p:nvPr/>
+        </p:nvSpPr>
+        <p:spPr>
+          <a:xfrm>
+            <a:off x="1207008" y="5221224"/>
+            <a:ext cx="8412480" cy="731520"/>
+          </a:xfrm>
+          <a:prstGeom prst="rect">
+            <a:avLst/>
+          </a:prstGeom>
+          <a:noFill/>
+        </p:spPr>
+        <p:txBody>
+          <a:bodyPr wrap="square" lIns="0" rIns="0" tIns="0" bIns="0" anchor="t">
+            <a:spAutoFit/>
+          </a:bodyPr>
+          <a:lstStyle/>
+          <a:p>
+            <a:pPr algn="l">
+              <a:lnSpc>
+                <a:spcPct val="135000"/>
+              </a:lnSpc>
+              <a:spcBef>
+                <a:spcPts val="0"/>
+              </a:spcBef>
+              <a:spcAft>
+                <a:spcPts val="300"/>
+              </a:spcAft>
+            </a:pPr>
+            <a:r>
+              <a:rPr sz="1350" b="1" i="0">
+                <a:solidFill>
+                  <a:srgbClr val="1A1A1A"/>
+                </a:solidFill>
+                <a:latin typeface="Calibri"/>
+              </a:rPr>
+              <a:t>Add company registry data</a:t>
+            </a:r>
+          </a:p>
+          <a:p>
+            <a:pPr>
+              <a:lnSpc>
+                <a:spcPct val="135000"/>
+              </a:lnSpc>
+              <a:spcBef>
+                <a:spcPts val="0"/>
+              </a:spcBef>
+              <a:spcAft>
+                <a:spcPts val="600"/>
+              </a:spcAft>
+            </a:pPr>
+            <a:r>
+              <a:rPr sz="1150" b="0" i="0">
+                <a:solidFill>
+                  <a:srgbClr val="4A4845"/>
+                </a:solidFill>
+                <a:latin typeface="Calibri"/>
+              </a:rPr>
+              <a:t>Tie each centre to its Indian legal entity, so the same company is never counted twice under two names.</a:t>
+            </a:r>
+          </a:p>
+        </p:txBody>
+      </p:sp>
+      <p:sp>
+        <p:nvSpPr>
+          <p:cNvPr id="20" name="Rectangle 19"/>
+          <p:cNvSpPr/>
+          <p:nvPr/>
+        </p:nvSpPr>
+        <p:spPr>
+          <a:xfrm>
+            <a:off x="10289743" y="5266944"/>
+            <a:ext cx="1188720" cy="237744"/>
+          </a:xfrm>
+          <a:prstGeom prst="rect">
+            <a:avLst/>
+          </a:prstGeom>
+          <a:solidFill>
+            <a:srgbClr val="F4F2EE"/>
+          </a:solidFill>
+          <a:ln>
+            <a:noFill/>
+          </a:ln>
+          <a:effectLst/>
+        </p:spPr>
+        <p:style>
+          <a:lnRef idx="1">
+            <a:schemeClr val="accent1"/>
+          </a:lnRef>
+          <a:fillRef idx="3">
+            <a:schemeClr val="accent1"/>
+          </a:fillRef>
+          <a:effectRef idx="2">
+            <a:schemeClr val="accent1"/>
+          </a:effectRef>
+          <a:fontRef idx="minor">
+            <a:schemeClr val="lt1"/>
+          </a:fontRef>
+        </p:style>
+        <p:txBody>
+          <a:bodyPr rtlCol="0" anchor="ctr" lIns="64008" rIns="64008" tIns="0" bIns="0"/>
+          <a:lstStyle/>
+          <a:p>
+            <a:pPr algn="ctr"/>
+            <a:r>
+              <a:rPr sz="950" b="1">
+                <a:solidFill>
+                  <a:srgbClr val="7A7772"/>
+                </a:solidFill>
+                <a:latin typeface="Calibri"/>
+              </a:rPr>
+              <a:t>Later</a:t>
+            </a:r>
+          </a:p>
+        </p:txBody>
+      </p:sp>
+      <p:sp>
+        <p:nvSpPr>
+          <p:cNvPr id="21" name="TextBox 20"/>
+          <p:cNvSpPr txBox="1"/>
+          <p:nvPr/>
+        </p:nvSpPr>
+        <p:spPr>
+          <a:xfrm>
+            <a:off x="713232" y="6382512"/>
+            <a:ext cx="10765231" cy="237744"/>
+          </a:xfrm>
+          <a:prstGeom prst="rect">
+            <a:avLst/>
+          </a:prstGeom>
+          <a:noFill/>
+        </p:spPr>
+        <p:txBody>
+          <a:bodyPr wrap="square" lIns="0" rIns="0" tIns="0" bIns="0" anchor="t">
+            <a:spAutoFit/>
+          </a:bodyPr>
+          <a:lstStyle/>
+          <a:p>
+            <a:pPr algn="l">
+              <a:lnSpc>
+                <a:spcPct val="135000"/>
+              </a:lnSpc>
+              <a:spcAft>
+                <a:spcPts val="0"/>
+              </a:spcAft>
+            </a:pPr>
+            <a:r>
+              <a:rPr sz="950" b="1">
+                <a:solidFill>
+                  <a:srgbClr val="7A7772"/>
+                </a:solidFill>
+                <a:latin typeface="Calibri"/>
+              </a:rPr>
+              <a:t>GCC Atlas</a:t>
+            </a:r>
+            <a:r>
+              <a:rPr sz="950" b="0">
+                <a:solidFill>
+                  <a:srgbClr val="7A7772"/>
+                </a:solidFill>
+                <a:latin typeface="Calibri"/>
+              </a:rPr>
+              <a:t>   ·   Next steps</a:t>
+            </a:r>
+          </a:p>
+        </p:txBody>
+      </p:sp>
+      <p:sp>
+        <p:nvSpPr>
+          <p:cNvPr id="22" name="TextBox 21"/>
+          <p:cNvSpPr txBox="1"/>
+          <p:nvPr/>
+        </p:nvSpPr>
+        <p:spPr>
+          <a:xfrm>
+            <a:off x="10564063" y="6382512"/>
+            <a:ext cx="914400" cy="237744"/>
+          </a:xfrm>
+          <a:prstGeom prst="rect">
+            <a:avLst/>
+          </a:prstGeom>
+          <a:noFill/>
+        </p:spPr>
+        <p:txBody>
+          <a:bodyPr wrap="square" lIns="0" rIns="0" tIns="0" bIns="0" anchor="t">
+            <a:spAutoFit/>
+          </a:bodyPr>
+          <a:lstStyle/>
+          <a:p>
+            <a:pPr algn="r">
+              <a:lnSpc>
+                <a:spcPct val="135000"/>
+              </a:lnSpc>
+              <a:spcBef>
+                <a:spcPts val="0"/>
+              </a:spcBef>
+              <a:spcAft>
+                <a:spcPts val="0"/>
+              </a:spcAft>
+            </a:pPr>
+            <a:r>
+              <a:rPr sz="950" b="0" i="0">
+                <a:solidFill>
+                  <a:srgbClr val="7A7772"/>
+                </a:solidFill>
+                <a:latin typeface="Calibri"/>
+              </a:rPr>
+              <a:t>18</a:t>
+            </a:r>
+          </a:p>
+        </p:txBody>
+      </p:sp>
+    </p:spTree>
+  </p:cSld>
+  <p:clrMapOvr>
+    <a:masterClrMapping/>
+  </p:clrMapOvr>
+</p:sld>
+</file>
+
+<file path=ppt/slides/slide19.xml><?xml version="1.0" encoding="utf-8"?>
+<p:sld xmlns:a="http://schemas.openxmlformats.org/drawingml/2006/main" xmlns:p="http://schemas.openxmlformats.org/presentationml/2006/main" xmlns:r="http://schemas.openxmlformats.org/officeDocument/2006/relationships">
+  <p:cSld>
+    <p:spTree>
+      <p:nvGrpSpPr>
+        <p:cNvPr id="1" name=""/>
+        <p:cNvGrpSpPr/>
+        <p:nvPr/>
+      </p:nvGrpSpPr>
+      <p:grpSpPr/>
+      <p:sp>
+        <p:nvSpPr>
+          <p:cNvPr id="2" name="Rectangle 1"/>
+          <p:cNvSpPr/>
+          <p:nvPr/>
+        </p:nvSpPr>
+        <p:spPr>
+          <a:xfrm>
+            <a:off x="0" y="0"/>
+            <a:ext cx="12191695" cy="6858000"/>
+          </a:xfrm>
+          <a:prstGeom prst="rect">
+            <a:avLst/>
+          </a:prstGeom>
+          <a:solidFill>
+            <a:srgbClr val="FFFFFF"/>
+          </a:solidFill>
+          <a:ln>
+            <a:noFill/>
+          </a:ln>
+          <a:effectLst/>
+        </p:spPr>
+        <p:style>
+          <a:lnRef idx="1">
+            <a:schemeClr val="accent1"/>
+          </a:lnRef>
+          <a:fillRef idx="3">
+            <a:schemeClr val="accent1"/>
+          </a:fillRef>
+          <a:effectRef idx="2">
+            <a:schemeClr val="accent1"/>
+          </a:effectRef>
+          <a:fontRef idx="minor">
+            <a:schemeClr val="lt1"/>
+          </a:fontRef>
+        </p:style>
+        <p:txBody>
+          <a:bodyPr rtlCol="0" anchor="ctr"/>
+          <a:lstStyle/>
+          <a:p>
+            <a:pPr algn="ctr"/>
+          </a:p>
+        </p:txBody>
+      </p:sp>
+      <p:sp>
+        <p:nvSpPr>
+          <p:cNvPr id="3" name="Rectangle 2"/>
+          <p:cNvSpPr/>
+          <p:nvPr/>
+        </p:nvSpPr>
+        <p:spPr>
+          <a:xfrm>
+            <a:off x="0" y="0"/>
+            <a:ext cx="118872" cy="6858000"/>
+          </a:xfrm>
+          <a:prstGeom prst="rect">
+            <a:avLst/>
+          </a:prstGeom>
+          <a:solidFill>
+            <a:srgbClr val="1F3A5F"/>
+          </a:solidFill>
+          <a:ln>
+            <a:noFill/>
+          </a:ln>
+          <a:effectLst/>
+        </p:spPr>
+        <p:style>
+          <a:lnRef idx="1">
+            <a:schemeClr val="accent1"/>
+          </a:lnRef>
+          <a:fillRef idx="3">
+            <a:schemeClr val="accent1"/>
+          </a:fillRef>
+          <a:effectRef idx="2">
+            <a:schemeClr val="accent1"/>
+          </a:effectRef>
+          <a:fontRef idx="minor">
+            <a:schemeClr val="lt1"/>
+          </a:fontRef>
+        </p:style>
+        <p:txBody>
+          <a:bodyPr rtlCol="0" anchor="ctr"/>
+          <a:lstStyle/>
+          <a:p>
+            <a:pPr algn="ctr"/>
+          </a:p>
+        </p:txBody>
+      </p:sp>
+      <p:sp>
+        <p:nvSpPr>
+          <p:cNvPr id="4" name="TextBox 3"/>
+          <p:cNvSpPr txBox="1"/>
+          <p:nvPr/>
+        </p:nvSpPr>
+        <p:spPr>
+          <a:xfrm>
+            <a:off x="1143000" y="1691640"/>
+            <a:ext cx="9509760" cy="914400"/>
+          </a:xfrm>
+          <a:prstGeom prst="rect">
+            <a:avLst/>
+          </a:prstGeom>
+          <a:noFill/>
+        </p:spPr>
+        <p:txBody>
+          <a:bodyPr wrap="square" lIns="0" rIns="0" tIns="0" bIns="0" anchor="t">
+            <a:spAutoFit/>
+          </a:bodyPr>
+          <a:lstStyle/>
+          <a:p>
+            <a:pPr algn="l">
+              <a:lnSpc>
+                <a:spcPct val="135000"/>
+              </a:lnSpc>
+              <a:spcBef>
+                <a:spcPts val="0"/>
+              </a:spcBef>
+              <a:spcAft>
+                <a:spcPts val="1600"/>
+              </a:spcAft>
+            </a:pPr>
+            <a:r>
+              <a:rPr sz="1500" b="1" i="0">
+                <a:solidFill>
+                  <a:srgbClr val="7A7772"/>
+                </a:solidFill>
+                <a:latin typeface="Calibri"/>
+              </a:rPr>
+              <a:t>The argument in one line</a:t>
+            </a:r>
+          </a:p>
+          <a:p>
+            <a:pPr>
+              <a:lnSpc>
+                <a:spcPct val="125000"/>
+              </a:lnSpc>
+              <a:spcBef>
+                <a:spcPts val="0"/>
+              </a:spcBef>
+              <a:spcAft>
+                <a:spcPts val="2000"/>
+              </a:spcAft>
+            </a:pPr>
+            <a:r>
+              <a:rPr sz="3000" b="0" i="0">
+                <a:solidFill>
+                  <a:srgbClr val="1A1A1A"/>
+                </a:solidFill>
+                <a:latin typeface="Georgia"/>
+              </a:rPr>
+              <a:t>This market does not lack information.
+It lacks information you can check.</a:t>
+            </a:r>
+          </a:p>
+        </p:txBody>
+      </p:sp>
+      <p:sp>
+        <p:nvSpPr>
+          <p:cNvPr id="5" name="Rectangle 4"/>
+          <p:cNvSpPr/>
+          <p:nvPr/>
+        </p:nvSpPr>
+        <p:spPr>
+          <a:xfrm>
+            <a:off x="1143000" y="3886200"/>
+            <a:ext cx="1828800" cy="11430"/>
+          </a:xfrm>
+          <a:prstGeom prst="rect">
+            <a:avLst/>
+          </a:prstGeom>
+          <a:solidFill>
+            <a:srgbClr val="1F3A5F"/>
+          </a:solidFill>
+          <a:ln>
+            <a:noFill/>
+          </a:ln>
+          <a:effectLst/>
+        </p:spPr>
+        <p:style>
+          <a:lnRef idx="1">
+            <a:schemeClr val="accent1"/>
+          </a:lnRef>
+          <a:fillRef idx="3">
+            <a:schemeClr val="accent1"/>
+          </a:fillRef>
+          <a:effectRef idx="2">
+            <a:schemeClr val="accent1"/>
+          </a:effectRef>
+          <a:fontRef idx="minor">
+            <a:schemeClr val="lt1"/>
+          </a:fontRef>
+        </p:style>
+        <p:txBody>
           <a:bodyPr rtlCol="0" anchor="ctr"/>
           <a:lstStyle/>
           <a:p>
@@ -10440,7 +12227,7 @@
                 </a:solidFill>
                 <a:latin typeface="Calibri"/>
               </a:rPr>
-              <a:t>18</a:t>
+              <a:t>19</a:t>
             </a:r>
           </a:p>
         </p:txBody>

</xml_diff>